<commit_message>
DP5 slides: simplify candidate module views, add timing annotations and commit timeline
Co-Authored-By: Claude Sonnet 5.5 <noreply@anthropic.com>
Claude-Session: https://claude.ai/code/session_01AuCqbPk6deqqdKjH41c27g
</commit_message>
<xml_diff>
--- a/doc-mk/DP5/DP5-slides-draft.pptx
+++ b/doc-mk/DP5/DP5-slides-draft.pptx
@@ -16241,14 +16241,14 @@
       </p:sp>
       <p:sp>
         <p:nvSpPr>
-          <p:cNvPr id="105" name="band"/>
+          <p:cNvPr id="105" name="C1 Control"/>
           <p:cNvSpPr/>
           <p:nvPr/>
         </p:nvSpPr>
         <p:spPr>
           <a:xfrm>
-            <a:off x="274320" y="1645920"/>
-            <a:ext cx="5303520" cy="594360"/>
+            <a:off x="274320" y="1627632"/>
+            <a:ext cx="2148840" cy="1874520"/>
           </a:xfrm>
           <a:prstGeom prst="rect">
             <a:avLst/>
@@ -16288,26 +16288,85 @@
           <a:p>
             <a:pPr algn="ctr"/>
             <a:r>
-              <a:rPr lang="ko-KR" altLang="en-US" sz="800" b="1" dirty="0">
+              <a:rPr lang="ko-KR" altLang="en-US" sz="850" b="1" dirty="0">
                 <a:solidFill>
                   <a:schemeClr val="tx1"/>
                 </a:solidFill>
               </a:rPr>
-              <a:t>Serving Engine (기존) + DP1</a:t>
+              <a:t>Control Plane (EngineCore)</a:t>
             </a:r>
           </a:p>
         </p:txBody>
       </p:sp>
       <p:sp>
         <p:nvSpPr>
-          <p:cNvPr id="106" name="DP1 Decision Plane"/>
+          <p:cNvPr id="106" name="C1 Data"/>
           <p:cNvSpPr/>
           <p:nvPr/>
         </p:nvSpPr>
         <p:spPr>
           <a:xfrm>
-            <a:off x="384048" y="1901952"/>
-            <a:ext cx="1188720" cy="274320"/>
+            <a:off x="3703320" y="1627632"/>
+            <a:ext cx="2240280" cy="1874520"/>
+          </a:xfrm>
+          <a:prstGeom prst="rect">
+            <a:avLst/>
+          </a:prstGeom>
+          <a:solidFill>
+            <a:schemeClr val="bg1">
+              <a:lumMod val="95000"/>
+            </a:schemeClr>
+          </a:solidFill>
+          <a:ln w="19050">
+            <a:solidFill>
+              <a:schemeClr val="tx1"/>
+            </a:solidFill>
+          </a:ln>
+        </p:spPr>
+        <p:style>
+          <a:lnRef idx="2">
+            <a:schemeClr val="accent1">
+              <a:shade val="50000"/>
+            </a:schemeClr>
+          </a:lnRef>
+          <a:fillRef idx="1">
+            <a:schemeClr val="accent1"/>
+          </a:fillRef>
+          <a:effectRef idx="0">
+            <a:schemeClr val="accent1"/>
+          </a:effectRef>
+          <a:fontRef idx="minor">
+            <a:schemeClr val="lt1"/>
+          </a:fontRef>
+        </p:style>
+        <p:txBody>
+          <a:bodyPr lIns="36000" tIns="18000" rIns="36000" bIns="0" rtlCol="0" anchor="t">
+            <a:noAutofit/>
+          </a:bodyPr>
+          <a:lstStyle/>
+          <a:p>
+            <a:pPr algn="ctr"/>
+            <a:r>
+              <a:rPr lang="ko-KR" altLang="en-US" sz="850" b="1" dirty="0">
+                <a:solidFill>
+                  <a:schemeClr val="tx1"/>
+                </a:solidFill>
+              </a:rPr>
+              <a:t>Data Plane (Worker)</a:t>
+            </a:r>
+          </a:p>
+        </p:txBody>
+      </p:sp>
+      <p:sp>
+        <p:nvSpPr>
+          <p:cNvPr id="107" name="Migration Coordinator"/>
+          <p:cNvSpPr/>
+          <p:nvPr/>
+        </p:nvSpPr>
+        <p:spPr>
+          <a:xfrm>
+            <a:off x="365760" y="1920240"/>
+            <a:ext cx="1965960" cy="329184"/>
           </a:xfrm>
           <a:prstGeom prst="rect">
             <a:avLst/>
@@ -16353,482 +16412,21 @@
                   <a:schemeClr val="tx1"/>
                 </a:solidFill>
               </a:rPr>
-              <a:t>DP1 Decision Plane</a:t>
+              <a:t>Migration Coordinator</a:t>
             </a:r>
           </a:p>
         </p:txBody>
       </p:sp>
       <p:sp>
         <p:nvSpPr>
-          <p:cNvPr id="107" name="Scheduler"/>
+          <p:cNvPr id="108" name="Data Location Store"/>
           <p:cNvSpPr/>
           <p:nvPr/>
         </p:nvSpPr>
         <p:spPr>
           <a:xfrm>
-            <a:off x="1691640" y="1901952"/>
-            <a:ext cx="868680" cy="274320"/>
-          </a:xfrm>
-          <a:prstGeom prst="rect">
-            <a:avLst/>
-          </a:prstGeom>
-          <a:solidFill>
-            <a:schemeClr val="bg1">
-              <a:lumMod val="95000"/>
-            </a:schemeClr>
-          </a:solidFill>
-          <a:ln w="12700">
-            <a:solidFill>
-              <a:schemeClr val="tx1"/>
-            </a:solidFill>
-          </a:ln>
-        </p:spPr>
-        <p:style>
-          <a:lnRef idx="2">
-            <a:schemeClr val="accent1">
-              <a:shade val="50000"/>
-            </a:schemeClr>
-          </a:lnRef>
-          <a:fillRef idx="1">
-            <a:schemeClr val="accent1"/>
-          </a:fillRef>
-          <a:effectRef idx="0">
-            <a:schemeClr val="accent1"/>
-          </a:effectRef>
-          <a:fontRef idx="minor">
-            <a:schemeClr val="lt1"/>
-          </a:fontRef>
-        </p:style>
-        <p:txBody>
-          <a:bodyPr lIns="36000" tIns="18000" rIns="36000" bIns="18000" rtlCol="0" anchor="ctr">
-            <a:noAutofit/>
-          </a:bodyPr>
-          <a:lstStyle/>
-          <a:p>
-            <a:pPr algn="ctr"/>
-            <a:r>
-              <a:rPr lang="ko-KR" altLang="en-US" sz="900" b="1" dirty="0">
-                <a:solidFill>
-                  <a:schemeClr val="tx1"/>
-                </a:solidFill>
-              </a:rPr>
-              <a:t>Scheduler</a:t>
-            </a:r>
-          </a:p>
-        </p:txBody>
-      </p:sp>
-      <p:sp>
-        <p:nvSpPr>
-          <p:cNvPr id="108" name="KVDataAdapter"/>
-          <p:cNvSpPr/>
-          <p:nvPr/>
-        </p:nvSpPr>
-        <p:spPr>
-          <a:xfrm>
-            <a:off x="2651760" y="1901952"/>
-            <a:ext cx="1051560" cy="274320"/>
-          </a:xfrm>
-          <a:prstGeom prst="rect">
-            <a:avLst/>
-          </a:prstGeom>
-          <a:solidFill>
-            <a:schemeClr val="bg1">
-              <a:lumMod val="95000"/>
-            </a:schemeClr>
-          </a:solidFill>
-          <a:ln w="12700">
-            <a:solidFill>
-              <a:schemeClr val="tx1"/>
-            </a:solidFill>
-          </a:ln>
-        </p:spPr>
-        <p:style>
-          <a:lnRef idx="2">
-            <a:schemeClr val="accent1">
-              <a:shade val="50000"/>
-            </a:schemeClr>
-          </a:lnRef>
-          <a:fillRef idx="1">
-            <a:schemeClr val="accent1"/>
-          </a:fillRef>
-          <a:effectRef idx="0">
-            <a:schemeClr val="accent1"/>
-          </a:effectRef>
-          <a:fontRef idx="minor">
-            <a:schemeClr val="lt1"/>
-          </a:fontRef>
-        </p:style>
-        <p:txBody>
-          <a:bodyPr lIns="36000" tIns="18000" rIns="36000" bIns="18000" rtlCol="0" anchor="ctr">
-            <a:noAutofit/>
-          </a:bodyPr>
-          <a:lstStyle/>
-          <a:p>
-            <a:pPr algn="ctr"/>
-            <a:r>
-              <a:rPr lang="ko-KR" altLang="en-US" sz="900" b="1" dirty="0">
-                <a:solidFill>
-                  <a:schemeClr val="tx1"/>
-                </a:solidFill>
-              </a:rPr>
-              <a:t>KVDataAdapter</a:t>
-            </a:r>
-          </a:p>
-        </p:txBody>
-      </p:sp>
-      <p:sp>
-        <p:nvSpPr>
-          <p:cNvPr id="109" name="Block Table"/>
-          <p:cNvSpPr/>
-          <p:nvPr/>
-        </p:nvSpPr>
-        <p:spPr>
-          <a:xfrm>
-            <a:off x="3794760" y="1901952"/>
-            <a:ext cx="777240" cy="274320"/>
-          </a:xfrm>
-          <a:prstGeom prst="rect">
-            <a:avLst/>
-          </a:prstGeom>
-          <a:solidFill>
-            <a:schemeClr val="bg1">
-              <a:lumMod val="95000"/>
-            </a:schemeClr>
-          </a:solidFill>
-          <a:ln w="12700">
-            <a:solidFill>
-              <a:schemeClr val="tx1"/>
-            </a:solidFill>
-          </a:ln>
-        </p:spPr>
-        <p:style>
-          <a:lnRef idx="2">
-            <a:schemeClr val="accent1">
-              <a:shade val="50000"/>
-            </a:schemeClr>
-          </a:lnRef>
-          <a:fillRef idx="1">
-            <a:schemeClr val="accent1"/>
-          </a:fillRef>
-          <a:effectRef idx="0">
-            <a:schemeClr val="accent1"/>
-          </a:effectRef>
-          <a:fontRef idx="minor">
-            <a:schemeClr val="lt1"/>
-          </a:fontRef>
-        </p:style>
-        <p:txBody>
-          <a:bodyPr lIns="36000" tIns="18000" rIns="36000" bIns="18000" rtlCol="0" anchor="ctr">
-            <a:noAutofit/>
-          </a:bodyPr>
-          <a:lstStyle/>
-          <a:p>
-            <a:pPr algn="ctr"/>
-            <a:r>
-              <a:rPr lang="ko-KR" altLang="en-US" sz="900" b="1" dirty="0">
-                <a:solidFill>
-                  <a:schemeClr val="tx1"/>
-                </a:solidFill>
-              </a:rPr>
-              <a:t>Block Table</a:t>
-            </a:r>
-          </a:p>
-        </p:txBody>
-      </p:sp>
-      <p:sp>
-        <p:nvSpPr>
-          <p:cNvPr id="110" name="Model Runner"/>
-          <p:cNvSpPr/>
-          <p:nvPr/>
-        </p:nvSpPr>
-        <p:spPr>
-          <a:xfrm>
-            <a:off x="4663440" y="1901952"/>
-            <a:ext cx="822960" cy="274320"/>
-          </a:xfrm>
-          <a:prstGeom prst="rect">
-            <a:avLst/>
-          </a:prstGeom>
-          <a:solidFill>
-            <a:schemeClr val="accent6">
-              <a:lumMod val="20000"/>
-              <a:lumOff val="80000"/>
-            </a:schemeClr>
-          </a:solidFill>
-          <a:ln w="12700">
-            <a:solidFill>
-              <a:schemeClr val="tx1"/>
-            </a:solidFill>
-          </a:ln>
-        </p:spPr>
-        <p:style>
-          <a:lnRef idx="2">
-            <a:schemeClr val="accent1">
-              <a:shade val="50000"/>
-            </a:schemeClr>
-          </a:lnRef>
-          <a:fillRef idx="1">
-            <a:schemeClr val="accent1"/>
-          </a:fillRef>
-          <a:effectRef idx="0">
-            <a:schemeClr val="accent1"/>
-          </a:effectRef>
-          <a:fontRef idx="minor">
-            <a:schemeClr val="lt1"/>
-          </a:fontRef>
-        </p:style>
-        <p:txBody>
-          <a:bodyPr lIns="36000" tIns="18000" rIns="36000" bIns="18000" rtlCol="0" anchor="ctr">
-            <a:noAutofit/>
-          </a:bodyPr>
-          <a:lstStyle/>
-          <a:p>
-            <a:pPr algn="ctr"/>
-            <a:r>
-              <a:rPr lang="ko-KR" altLang="en-US" sz="900" b="1" dirty="0">
-                <a:solidFill>
-                  <a:schemeClr val="tx1"/>
-                </a:solidFill>
-              </a:rPr>
-              <a:t>Model Runner</a:t>
-            </a:r>
-          </a:p>
-        </p:txBody>
-      </p:sp>
-      <p:sp>
-        <p:nvSpPr>
-          <p:cNvPr id="111" name="Control Plane (EngineCore)"/>
-          <p:cNvSpPr/>
-          <p:nvPr/>
-        </p:nvSpPr>
-        <p:spPr>
-          <a:xfrm>
-            <a:off x="274320" y="2450592"/>
-            <a:ext cx="3108960" cy="1709928"/>
-          </a:xfrm>
-          <a:prstGeom prst="rect">
-            <a:avLst/>
-          </a:prstGeom>
-          <a:solidFill>
-            <a:schemeClr val="accent5">
-              <a:lumMod val="20000"/>
-              <a:lumOff val="80000"/>
-            </a:schemeClr>
-          </a:solidFill>
-          <a:ln w="19050">
-            <a:solidFill>
-              <a:schemeClr val="tx1"/>
-            </a:solidFill>
-          </a:ln>
-        </p:spPr>
-        <p:style>
-          <a:lnRef idx="2">
-            <a:schemeClr val="accent1">
-              <a:shade val="50000"/>
-            </a:schemeClr>
-          </a:lnRef>
-          <a:fillRef idx="1">
-            <a:schemeClr val="accent1"/>
-          </a:fillRef>
-          <a:effectRef idx="0">
-            <a:schemeClr val="accent1"/>
-          </a:effectRef>
-          <a:fontRef idx="minor">
-            <a:schemeClr val="lt1"/>
-          </a:fontRef>
-        </p:style>
-        <p:txBody>
-          <a:bodyPr lIns="36000" tIns="18000" rIns="36000" bIns="0" rtlCol="0" anchor="t">
-            <a:noAutofit/>
-          </a:bodyPr>
-          <a:lstStyle/>
-          <a:p>
-            <a:pPr algn="ctr"/>
-            <a:r>
-              <a:rPr lang="ko-KR" altLang="en-US" sz="850" b="1" dirty="0">
-                <a:solidFill>
-                  <a:schemeClr val="tx1"/>
-                </a:solidFill>
-              </a:rPr>
-              <a:t>Control Plane (EngineCore)</a:t>
-            </a:r>
-          </a:p>
-        </p:txBody>
-      </p:sp>
-      <p:sp>
-        <p:nvSpPr>
-          <p:cNvPr id="112" name="Control Plane (EngineCore) tab"/>
-          <p:cNvSpPr/>
-          <p:nvPr/>
-        </p:nvSpPr>
-        <p:spPr>
-          <a:xfrm>
-            <a:off x="274320" y="2331720"/>
-            <a:ext cx="241402" cy="119786"/>
-          </a:xfrm>
-          <a:prstGeom prst="rect">
-            <a:avLst/>
-          </a:prstGeom>
-          <a:solidFill>
-            <a:schemeClr val="accent5">
-              <a:lumMod val="20000"/>
-              <a:lumOff val="80000"/>
-            </a:schemeClr>
-          </a:solidFill>
-          <a:ln w="19050">
-            <a:solidFill>
-              <a:schemeClr val="tx1"/>
-            </a:solidFill>
-          </a:ln>
-        </p:spPr>
-        <p:style>
-          <a:lnRef idx="2">
-            <a:schemeClr val="accent1">
-              <a:shade val="50000"/>
-            </a:schemeClr>
-          </a:lnRef>
-          <a:fillRef idx="1">
-            <a:schemeClr val="accent1"/>
-          </a:fillRef>
-          <a:effectRef idx="0">
-            <a:schemeClr val="accent1"/>
-          </a:effectRef>
-          <a:fontRef idx="minor">
-            <a:schemeClr val="lt1"/>
-          </a:fontRef>
-        </p:style>
-        <p:txBody>
-          <a:bodyPr lIns="36000" tIns="18000" rIns="36000" bIns="18000" rtlCol="0" anchor="ctr">
-            <a:noAutofit/>
-          </a:bodyPr>
-          <a:lstStyle/>
-          <a:p>
-            <a:endParaRPr lang="ko-KR"/>
-          </a:p>
-        </p:txBody>
-      </p:sp>
-      <p:sp>
-        <p:nvSpPr>
-          <p:cNvPr id="113" name="Data Transfer Plane (Worker)"/>
-          <p:cNvSpPr/>
-          <p:nvPr/>
-        </p:nvSpPr>
-        <p:spPr>
-          <a:xfrm>
-            <a:off x="3566160" y="2450592"/>
-            <a:ext cx="2011680" cy="1709928"/>
-          </a:xfrm>
-          <a:prstGeom prst="rect">
-            <a:avLst/>
-          </a:prstGeom>
-          <a:solidFill>
-            <a:schemeClr val="accent5">
-              <a:lumMod val="20000"/>
-              <a:lumOff val="80000"/>
-            </a:schemeClr>
-          </a:solidFill>
-          <a:ln w="19050">
-            <a:solidFill>
-              <a:schemeClr val="tx1"/>
-            </a:solidFill>
-          </a:ln>
-        </p:spPr>
-        <p:style>
-          <a:lnRef idx="2">
-            <a:schemeClr val="accent1">
-              <a:shade val="50000"/>
-            </a:schemeClr>
-          </a:lnRef>
-          <a:fillRef idx="1">
-            <a:schemeClr val="accent1"/>
-          </a:fillRef>
-          <a:effectRef idx="0">
-            <a:schemeClr val="accent1"/>
-          </a:effectRef>
-          <a:fontRef idx="minor">
-            <a:schemeClr val="lt1"/>
-          </a:fontRef>
-        </p:style>
-        <p:txBody>
-          <a:bodyPr lIns="36000" tIns="18000" rIns="36000" bIns="0" rtlCol="0" anchor="t">
-            <a:noAutofit/>
-          </a:bodyPr>
-          <a:lstStyle/>
-          <a:p>
-            <a:pPr algn="ctr"/>
-            <a:r>
-              <a:rPr lang="ko-KR" altLang="en-US" sz="850" b="1" dirty="0">
-                <a:solidFill>
-                  <a:schemeClr val="tx1"/>
-                </a:solidFill>
-              </a:rPr>
-              <a:t>Data Transfer Plane (Worker)</a:t>
-            </a:r>
-          </a:p>
-        </p:txBody>
-      </p:sp>
-      <p:sp>
-        <p:nvSpPr>
-          <p:cNvPr id="114" name="Data Transfer Plane (Worker) tab"/>
-          <p:cNvSpPr/>
-          <p:nvPr/>
-        </p:nvSpPr>
-        <p:spPr>
-          <a:xfrm>
-            <a:off x="3566160" y="2331720"/>
-            <a:ext cx="241402" cy="119786"/>
-          </a:xfrm>
-          <a:prstGeom prst="rect">
-            <a:avLst/>
-          </a:prstGeom>
-          <a:solidFill>
-            <a:schemeClr val="accent5">
-              <a:lumMod val="20000"/>
-              <a:lumOff val="80000"/>
-            </a:schemeClr>
-          </a:solidFill>
-          <a:ln w="19050">
-            <a:solidFill>
-              <a:schemeClr val="tx1"/>
-            </a:solidFill>
-          </a:ln>
-        </p:spPr>
-        <p:style>
-          <a:lnRef idx="2">
-            <a:schemeClr val="accent1">
-              <a:shade val="50000"/>
-            </a:schemeClr>
-          </a:lnRef>
-          <a:fillRef idx="1">
-            <a:schemeClr val="accent1"/>
-          </a:fillRef>
-          <a:effectRef idx="0">
-            <a:schemeClr val="accent1"/>
-          </a:effectRef>
-          <a:fontRef idx="minor">
-            <a:schemeClr val="lt1"/>
-          </a:fontRef>
-        </p:style>
-        <p:txBody>
-          <a:bodyPr lIns="36000" tIns="18000" rIns="36000" bIns="18000" rtlCol="0" anchor="ctr">
-            <a:noAutofit/>
-          </a:bodyPr>
-          <a:lstStyle/>
-          <a:p>
-            <a:endParaRPr lang="ko-KR"/>
-          </a:p>
-        </p:txBody>
-      </p:sp>
-      <p:sp>
-        <p:nvSpPr>
-          <p:cNvPr id="115" name="Migration Coordinator"/>
-          <p:cNvSpPr/>
-          <p:nvPr/>
-        </p:nvSpPr>
-        <p:spPr>
-          <a:xfrm>
-            <a:off x="365760" y="2743200"/>
-            <a:ext cx="1417320" cy="310896"/>
+            <a:off x="365760" y="2313432"/>
+            <a:ext cx="1965960" cy="329184"/>
           </a:xfrm>
           <a:prstGeom prst="rect">
             <a:avLst/>
@@ -16874,21 +16472,32 @@
                   <a:schemeClr val="tx1"/>
                 </a:solidFill>
               </a:rPr>
-              <a:t>Migration Coordinator</a:t>
+              <a:t>Data Location Store</a:t>
+            </a:r>
+          </a:p>
+          <a:p>
+            <a:pPr algn="ctr"/>
+            <a:r>
+              <a:rPr lang="ko-KR" altLang="en-US" sz="750" dirty="0">
+                <a:solidFill>
+                  <a:schemeClr val="tx1"/>
+                </a:solidFill>
+              </a:rPr>
+              <a:t>(authoritative)</a:t>
             </a:r>
           </a:p>
         </p:txBody>
       </p:sp>
       <p:sp>
         <p:nvSpPr>
-          <p:cNvPr id="116" name="Migration Planner / Queue"/>
+          <p:cNvPr id="109" name="Completion Reconciler"/>
           <p:cNvSpPr/>
           <p:nvPr/>
         </p:nvSpPr>
         <p:spPr>
           <a:xfrm>
-            <a:off x="1874520" y="2743200"/>
-            <a:ext cx="1417320" cy="310896"/>
+            <a:off x="365760" y="2706624"/>
+            <a:ext cx="1965960" cy="329184"/>
           </a:xfrm>
           <a:prstGeom prst="rect">
             <a:avLst/>
@@ -16934,21 +16543,32 @@
                   <a:schemeClr val="tx1"/>
                 </a:solidFill>
               </a:rPr>
-              <a:t>Migration Planner / Queue</a:t>
+              <a:t>Completion Reconciler</a:t>
+            </a:r>
+          </a:p>
+          <a:p>
+            <a:pPr algn="ctr"/>
+            <a:r>
+              <a:rPr lang="ko-KR" altLang="en-US" sz="750" dirty="0">
+                <a:solidFill>
+                  <a:schemeClr val="tx1"/>
+                </a:solidFill>
+              </a:rPr>
+              <a:t>다음 schedule() 시작 시 commit</a:t>
             </a:r>
           </a:p>
         </p:txBody>
       </p:sp>
       <p:sp>
         <p:nvSpPr>
-          <p:cNvPr id="117" name="Data Location Store"/>
+          <p:cNvPr id="110" name="Epoch Tracker"/>
           <p:cNvSpPr/>
           <p:nvPr/>
         </p:nvSpPr>
         <p:spPr>
           <a:xfrm>
-            <a:off x="365760" y="3127248"/>
-            <a:ext cx="1417320" cy="310896"/>
+            <a:off x="365760" y="3099816"/>
+            <a:ext cx="1965960" cy="329184"/>
           </a:xfrm>
           <a:prstGeom prst="rect">
             <a:avLst/>
@@ -16994,7 +16614,7 @@
                   <a:schemeClr val="tx1"/>
                 </a:solidFill>
               </a:rPr>
-              <a:t>Data Location Store</a:t>
+              <a:t>Epoch Tracker</a:t>
             </a:r>
           </a:p>
           <a:p>
@@ -17005,21 +16625,21 @@
                   <a:schemeClr val="tx1"/>
                 </a:solidFill>
               </a:rPr>
-              <a:t>(authoritative)</a:t>
+              <a:t>마지막 참조 step 종료 후 슬롯 해제</a:t>
             </a:r>
           </a:p>
         </p:txBody>
       </p:sp>
       <p:sp>
         <p:nvSpPr>
-          <p:cNvPr id="118" name="Completion Reconciler"/>
+          <p:cNvPr id="111" name="Migration Executor"/>
           <p:cNvSpPr/>
           <p:nvPr/>
         </p:nvSpPr>
         <p:spPr>
           <a:xfrm>
-            <a:off x="1874520" y="3127248"/>
-            <a:ext cx="1417320" cy="310896"/>
+            <a:off x="3794760" y="1920240"/>
+            <a:ext cx="2057400" cy="329184"/>
           </a:xfrm>
           <a:prstGeom prst="rect">
             <a:avLst/>
@@ -17065,7 +16685,7 @@
                   <a:schemeClr val="tx1"/>
                 </a:solidFill>
               </a:rPr>
-              <a:t>Completion Reconciler</a:t>
+              <a:t>Migration Executor</a:t>
             </a:r>
           </a:p>
           <a:p>
@@ -17076,21 +16696,21 @@
                   <a:schemeClr val="tx1"/>
                 </a:solidFill>
               </a:rPr>
-              <a:t>(step 경계 commit)</a:t>
+              <a:t>복사 실행</a:t>
             </a:r>
           </a:p>
         </p:txBody>
       </p:sp>
       <p:sp>
         <p:nvSpPr>
-          <p:cNvPr id="119" name="Epoch Tracker"/>
+          <p:cNvPr id="112" name="Model Runner"/>
           <p:cNvSpPr/>
           <p:nvPr/>
         </p:nvSpPr>
         <p:spPr>
           <a:xfrm>
-            <a:off x="1874520" y="3511296"/>
-            <a:ext cx="1417320" cy="310896"/>
+            <a:off x="3794760" y="2706624"/>
+            <a:ext cx="2057400" cy="329184"/>
           </a:xfrm>
           <a:prstGeom prst="rect">
             <a:avLst/>
@@ -17136,7 +16756,7 @@
                   <a:schemeClr val="tx1"/>
                 </a:solidFill>
               </a:rPr>
-              <a:t>Epoch Tracker</a:t>
+              <a:t>Model Runner</a:t>
             </a:r>
           </a:p>
           <a:p>
@@ -17147,141 +16767,90 @@
                   <a:schemeClr val="tx1"/>
                 </a:solidFill>
               </a:rPr>
-              <a:t>(참조 슬롯, 해제 보류)</a:t>
+              <a:t>dependency 대기 (barrier)</a:t>
             </a:r>
           </a:p>
         </p:txBody>
       </p:sp>
-      <p:sp>
-        <p:nvSpPr>
-          <p:cNvPr id="120" name="Migration Executor"/>
-          <p:cNvSpPr/>
-          <p:nvPr/>
-        </p:nvSpPr>
-        <p:spPr>
-          <a:xfrm>
-            <a:off x="3657600" y="2743200"/>
-            <a:ext cx="1828800" cy="310896"/>
-          </a:xfrm>
-          <a:prstGeom prst="rect">
-            <a:avLst/>
-          </a:prstGeom>
-          <a:solidFill>
-            <a:schemeClr val="accent6">
-              <a:lumMod val="20000"/>
-              <a:lumOff val="80000"/>
-            </a:schemeClr>
-          </a:solidFill>
+      <p:cxnSp>
+        <p:nvCxnSpPr>
+          <p:cNvPr id="113" name="c1"/>
+          <p:cNvCxnSpPr/>
+          <p:nvPr/>
+        </p:nvCxnSpPr>
+        <p:spPr>
+          <a:xfrm>
+            <a:off x="1353312" y="2249424"/>
+            <a:ext cx="0" cy="64008"/>
+          </a:xfrm>
+          <a:prstGeom prst="line">
+            <a:avLst/>
+          </a:prstGeom>
           <a:ln w="12700">
             <a:solidFill>
               <a:schemeClr val="tx1"/>
             </a:solidFill>
+            <a:prstDash val="dash"/>
+            <a:tailEnd type="arrow"/>
           </a:ln>
         </p:spPr>
-        <p:style>
-          <a:lnRef idx="2">
-            <a:schemeClr val="accent1">
-              <a:shade val="50000"/>
-            </a:schemeClr>
-          </a:lnRef>
-          <a:fillRef idx="1">
-            <a:schemeClr val="accent1"/>
-          </a:fillRef>
-          <a:effectRef idx="0">
-            <a:schemeClr val="accent1"/>
-          </a:effectRef>
-          <a:fontRef idx="minor">
-            <a:schemeClr val="lt1"/>
-          </a:fontRef>
-        </p:style>
-        <p:txBody>
-          <a:bodyPr lIns="36000" tIns="18000" rIns="36000" bIns="18000" rtlCol="0" anchor="ctr">
-            <a:noAutofit/>
-          </a:bodyPr>
-          <a:lstStyle/>
-          <a:p>
-            <a:pPr algn="ctr"/>
-            <a:r>
-              <a:rPr lang="ko-KR" altLang="en-US" sz="900" b="1" dirty="0">
-                <a:solidFill>
-                  <a:schemeClr val="tx1"/>
-                </a:solidFill>
-              </a:rPr>
-              <a:t>Migration Executor</a:t>
-            </a:r>
-          </a:p>
-        </p:txBody>
-      </p:sp>
-      <p:sp>
-        <p:nvSpPr>
-          <p:cNvPr id="121" name="Transfer Router · Handler"/>
-          <p:cNvSpPr/>
-          <p:nvPr/>
-        </p:nvSpPr>
-        <p:spPr>
-          <a:xfrm>
-            <a:off x="3657600" y="3127248"/>
-            <a:ext cx="1828800" cy="310896"/>
-          </a:xfrm>
-          <a:prstGeom prst="rect">
-            <a:avLst/>
-          </a:prstGeom>
-          <a:solidFill>
-            <a:schemeClr val="accent6">
-              <a:lumMod val="20000"/>
-              <a:lumOff val="80000"/>
-            </a:schemeClr>
-          </a:solidFill>
+      </p:cxnSp>
+      <p:cxnSp>
+        <p:nvCxnSpPr>
+          <p:cNvPr id="114" name="c2"/>
+          <p:cNvCxnSpPr/>
+          <p:nvPr/>
+        </p:nvCxnSpPr>
+        <p:spPr>
+          <a:xfrm flipV="1">
+            <a:off x="1353312" y="2642616"/>
+            <a:ext cx="0" cy="64008"/>
+          </a:xfrm>
+          <a:prstGeom prst="line">
+            <a:avLst/>
+          </a:prstGeom>
           <a:ln w="12700">
             <a:solidFill>
               <a:schemeClr val="tx1"/>
             </a:solidFill>
+            <a:prstDash val="dash"/>
+            <a:tailEnd type="arrow"/>
           </a:ln>
         </p:spPr>
-        <p:style>
-          <a:lnRef idx="2">
-            <a:schemeClr val="accent1">
-              <a:shade val="50000"/>
-            </a:schemeClr>
-          </a:lnRef>
-          <a:fillRef idx="1">
-            <a:schemeClr val="accent1"/>
-          </a:fillRef>
-          <a:effectRef idx="0">
-            <a:schemeClr val="accent1"/>
-          </a:effectRef>
-          <a:fontRef idx="minor">
-            <a:schemeClr val="lt1"/>
-          </a:fontRef>
-        </p:style>
-        <p:txBody>
-          <a:bodyPr lIns="36000" tIns="18000" rIns="36000" bIns="18000" rtlCol="0" anchor="ctr">
-            <a:noAutofit/>
-          </a:bodyPr>
-          <a:lstStyle/>
-          <a:p>
-            <a:pPr algn="ctr"/>
-            <a:r>
-              <a:rPr lang="ko-KR" altLang="en-US" sz="900" b="1" dirty="0">
-                <a:solidFill>
-                  <a:schemeClr val="tx1"/>
-                </a:solidFill>
-              </a:rPr>
-              <a:t>Transfer Router · Handler</a:t>
-            </a:r>
-          </a:p>
-        </p:txBody>
-      </p:sp>
+      </p:cxnSp>
       <p:cxnSp>
         <p:nvCxnSpPr>
-          <p:cNvPr id="122" name="intent"/>
+          <p:cNvPr id="115" name="c3"/>
           <p:cNvCxnSpPr/>
           <p:nvPr/>
         </p:nvCxnSpPr>
         <p:spPr>
           <a:xfrm>
-            <a:off x="1078992" y="2176272"/>
-            <a:ext cx="0" cy="566928"/>
+            <a:off x="1353312" y="3035808"/>
+            <a:ext cx="0" cy="64008"/>
+          </a:xfrm>
+          <a:prstGeom prst="line">
+            <a:avLst/>
+          </a:prstGeom>
+          <a:ln w="12700">
+            <a:solidFill>
+              <a:schemeClr val="tx1"/>
+            </a:solidFill>
+            <a:prstDash val="dash"/>
+            <a:tailEnd type="arrow"/>
+          </a:ln>
+        </p:spPr>
+      </p:cxnSp>
+      <p:cxnSp>
+        <p:nvCxnSpPr>
+          <p:cNvPr id="116" name="command"/>
+          <p:cNvCxnSpPr/>
+          <p:nvPr/>
+        </p:nvCxnSpPr>
+        <p:spPr>
+          <a:xfrm>
+            <a:off x="2331720" y="2029968"/>
+            <a:ext cx="1463040" cy="0"/>
           </a:xfrm>
           <a:prstGeom prst="line">
             <a:avLst/>
@@ -17295,131 +16864,50 @@
           </a:ln>
         </p:spPr>
       </p:cxnSp>
-      <p:cxnSp>
-        <p:nvCxnSpPr>
-          <p:cNvPr id="123" name="c1"/>
-          <p:cNvCxnSpPr/>
-          <p:nvPr/>
-        </p:nvCxnSpPr>
-        <p:spPr>
-          <a:xfrm>
-            <a:off x="1783080" y="2898648"/>
-            <a:ext cx="91440" cy="0"/>
-          </a:xfrm>
-          <a:prstGeom prst="line">
-            <a:avLst/>
-          </a:prstGeom>
-          <a:ln w="12700">
-            <a:solidFill>
-              <a:schemeClr val="tx1"/>
-            </a:solidFill>
-            <a:prstDash val="dash"/>
-            <a:tailEnd type="arrow"/>
-          </a:ln>
-        </p:spPr>
-      </p:cxnSp>
-      <p:cxnSp>
-        <p:nvCxnSpPr>
-          <p:cNvPr id="124" name="c2"/>
-          <p:cNvCxnSpPr/>
-          <p:nvPr/>
-        </p:nvCxnSpPr>
-        <p:spPr>
-          <a:xfrm>
-            <a:off x="1078992" y="3054096"/>
-            <a:ext cx="0" cy="73152"/>
-          </a:xfrm>
-          <a:prstGeom prst="line">
-            <a:avLst/>
-          </a:prstGeom>
-          <a:ln w="12700">
-            <a:solidFill>
-              <a:schemeClr val="tx1"/>
-            </a:solidFill>
-            <a:prstDash val="dash"/>
-            <a:tailEnd type="arrow"/>
-          </a:ln>
-        </p:spPr>
-      </p:cxnSp>
-      <p:cxnSp>
-        <p:nvCxnSpPr>
-          <p:cNvPr id="125" name="c3"/>
-          <p:cNvCxnSpPr/>
-          <p:nvPr/>
-        </p:nvCxnSpPr>
-        <p:spPr>
-          <a:xfrm flipH="1">
-            <a:off x="1783080" y="3282696"/>
-            <a:ext cx="91440" cy="0"/>
-          </a:xfrm>
-          <a:prstGeom prst="line">
-            <a:avLst/>
-          </a:prstGeom>
-          <a:ln w="12700">
-            <a:solidFill>
-              <a:schemeClr val="tx1"/>
-            </a:solidFill>
-            <a:prstDash val="dash"/>
-            <a:tailEnd type="arrow"/>
-          </a:ln>
-        </p:spPr>
-      </p:cxnSp>
-      <p:cxnSp>
-        <p:nvCxnSpPr>
-          <p:cNvPr id="126" name="c4"/>
-          <p:cNvCxnSpPr/>
-          <p:nvPr/>
-        </p:nvCxnSpPr>
-        <p:spPr>
-          <a:xfrm>
-            <a:off x="2578608" y="3438144"/>
-            <a:ext cx="0" cy="73152"/>
-          </a:xfrm>
-          <a:prstGeom prst="line">
-            <a:avLst/>
-          </a:prstGeom>
-          <a:ln w="12700">
-            <a:solidFill>
-              <a:schemeClr val="tx1"/>
-            </a:solidFill>
-            <a:prstDash val="dash"/>
-            <a:tailEnd type="arrow"/>
-          </a:ln>
-        </p:spPr>
-      </p:cxnSp>
-      <p:cxnSp>
-        <p:nvCxnSpPr>
-          <p:cNvPr id="127" name="command"/>
-          <p:cNvCxnSpPr/>
-          <p:nvPr/>
-        </p:nvCxnSpPr>
-        <p:spPr>
-          <a:xfrm>
-            <a:off x="3291840" y="2834640"/>
-            <a:ext cx="365760" cy="0"/>
-          </a:xfrm>
-          <a:prstGeom prst="line">
-            <a:avLst/>
-          </a:prstGeom>
-          <a:ln w="28575">
-            <a:solidFill>
-              <a:schemeClr val="tx1"/>
-            </a:solidFill>
-            <a:prstDash val="dash"/>
-            <a:tailEnd type="arrow"/>
-          </a:ln>
-        </p:spPr>
-      </p:cxnSp>
       <p:sp>
         <p:nvSpPr>
-          <p:cNvPr id="128" name="completion"/>
+          <p:cNvPr id="117" name="l1"/>
+          <p:cNvSpPr txBox="1"/>
+          <p:nvPr/>
+        </p:nvSpPr>
+        <p:spPr>
+          <a:xfrm>
+            <a:off x="2423160" y="1828800"/>
+            <a:ext cx="1280160" cy="182880"/>
+          </a:xfrm>
+          <a:prstGeom prst="rect">
+            <a:avLst/>
+          </a:prstGeom>
+          <a:noFill/>
+        </p:spPr>
+        <p:txBody>
+          <a:bodyPr wrap="square" lIns="0" tIns="0" rIns="0" bIns="0" rtlCol="0" anchor="ctr">
+            <a:noAutofit/>
+          </a:bodyPr>
+          <a:lstStyle/>
+          <a:p>
+            <a:pPr algn="ctr"/>
+            <a:r>
+              <a:rPr lang="ko-KR" altLang="en-US" sz="650" b="1" dirty="0">
+                <a:solidFill>
+                  <a:schemeClr val="tx1"/>
+                </a:solidFill>
+              </a:rPr>
+              <a:t>command + dependency</a:t>
+            </a:r>
+          </a:p>
+        </p:txBody>
+      </p:sp>
+      <p:sp>
+        <p:nvSpPr>
+          <p:cNvPr id="118" name="completion"/>
           <p:cNvSpPr/>
           <p:nvPr/>
         </p:nvSpPr>
         <p:spPr>
           <a:xfrm>
-            <a:off x="3291840" y="2990088"/>
-            <a:ext cx="365760" cy="292608"/>
+            <a:off x="2331720" y="2167128"/>
+            <a:ext cx="1463040" cy="704088"/>
           </a:xfrm>
           <a:custGeom>
             <a:avLst/>
@@ -17428,18 +16916,18 @@
             <a:cxnLst/>
             <a:rect l="0" t="0" r="r" b="b"/>
             <a:pathLst>
-              <a:path w="365760" h="292608" fill="none">
+              <a:path w="1463040" h="704088" fill="none">
                 <a:moveTo>
-                  <a:pt x="365760" y="0"/>
+                  <a:pt x="1463040" y="0"/>
                 </a:moveTo>
                 <a:lnTo>
-                  <a:pt x="182880" y="0"/>
+                  <a:pt x="1234440" y="0"/>
                 </a:lnTo>
                 <a:lnTo>
-                  <a:pt x="182880" y="292608"/>
+                  <a:pt x="1234440" y="704088"/>
                 </a:lnTo>
                 <a:lnTo>
-                  <a:pt x="0" y="292608"/>
+                  <a:pt x="0" y="704088"/>
                 </a:lnTo>
               </a:path>
             </a:pathLst>
@@ -17454,39 +16942,50 @@
           </a:ln>
         </p:spPr>
       </p:sp>
+      <p:sp>
+        <p:nvSpPr>
+          <p:cNvPr id="119" name="l2"/>
+          <p:cNvSpPr txBox="1"/>
+          <p:nvPr/>
+        </p:nvSpPr>
+        <p:spPr>
+          <a:xfrm>
+            <a:off x="2377440" y="2898648"/>
+            <a:ext cx="1188720" cy="128016"/>
+          </a:xfrm>
+          <a:prstGeom prst="rect">
+            <a:avLst/>
+          </a:prstGeom>
+          <a:noFill/>
+        </p:spPr>
+        <p:txBody>
+          <a:bodyPr wrap="square" lIns="0" tIns="0" rIns="0" bIns="0" rtlCol="0" anchor="ctr">
+            <a:noAutofit/>
+          </a:bodyPr>
+          <a:lstStyle/>
+          <a:p>
+            <a:pPr algn="ctr"/>
+            <a:r>
+              <a:rPr lang="ko-KR" altLang="en-US" sz="600" b="1" dirty="0">
+                <a:solidFill>
+                  <a:schemeClr val="tx1"/>
+                </a:solidFill>
+              </a:rPr>
+              <a:t>completion (step 끝 보고)</a:t>
+            </a:r>
+          </a:p>
+        </p:txBody>
+      </p:sp>
       <p:cxnSp>
         <p:nvCxnSpPr>
-          <p:cNvPr id="129" name="c5"/>
+          <p:cNvPr id="120" name="dep"/>
           <p:cNvCxnSpPr/>
           <p:nvPr/>
         </p:nvCxnSpPr>
         <p:spPr>
           <a:xfrm>
-            <a:off x="4572000" y="3054096"/>
-            <a:ext cx="0" cy="73152"/>
-          </a:xfrm>
-          <a:prstGeom prst="line">
-            <a:avLst/>
-          </a:prstGeom>
-          <a:ln w="12700">
-            <a:solidFill>
-              <a:schemeClr val="tx1"/>
-            </a:solidFill>
-            <a:prstDash val="dash"/>
-            <a:tailEnd type="arrow"/>
-          </a:ln>
-        </p:spPr>
-      </p:cxnSp>
-      <p:cxnSp>
-        <p:nvCxnSpPr>
-          <p:cNvPr id="130" name="dep"/>
-          <p:cNvCxnSpPr/>
-          <p:nvPr/>
-        </p:nvCxnSpPr>
-        <p:spPr>
-          <a:xfrm>
-            <a:off x="5074920" y="2176272"/>
-            <a:ext cx="0" cy="566928"/>
+            <a:off x="4818888" y="2249424"/>
+            <a:ext cx="0" cy="457200"/>
           </a:xfrm>
           <a:prstGeom prst="line">
             <a:avLst/>
@@ -17503,14 +17002,14 @@
       </p:cxnSp>
       <p:sp>
         <p:nvSpPr>
-          <p:cNvPr id="131" name="legend"/>
+          <p:cNvPr id="121" name="l3"/>
           <p:cNvSpPr txBox="1"/>
           <p:nvPr/>
         </p:nvSpPr>
         <p:spPr>
           <a:xfrm>
-            <a:off x="365760" y="3493008"/>
-            <a:ext cx="1463040" cy="548640"/>
+            <a:off x="4846320" y="2276856"/>
+            <a:ext cx="1097280" cy="182880"/>
           </a:xfrm>
           <a:prstGeom prst="rect">
             <a:avLst/>
@@ -17525,82 +17024,26 @@
           <a:p>
             <a:pPr algn="l"/>
             <a:r>
-              <a:rPr lang="ko-KR" altLang="en-US" sz="650" dirty="0">
+              <a:rPr lang="ko-KR" altLang="en-US" sz="600" dirty="0">
                 <a:solidFill>
-                  <a:schemeClr val="tx1"/>
+                  <a:srgbClr val="595959"/>
                 </a:solidFill>
               </a:rPr>
-              <a:t>굵은 선:</a:t>
-            </a:r>
-          </a:p>
-          <a:p>
-            <a:pPr algn="l"/>
-            <a:r>
-              <a:rPr lang="ko-KR" altLang="en-US" sz="650" dirty="0">
-                <a:solidFill>
-                  <a:schemeClr val="tx1"/>
-                </a:solidFill>
-              </a:rPr>
-              <a:t>→ MigrationIntent · command</a:t>
-            </a:r>
-          </a:p>
-          <a:p>
-            <a:pPr algn="l"/>
-            <a:r>
-              <a:rPr lang="ko-KR" altLang="en-US" sz="650" dirty="0">
-                <a:solidFill>
-                  <a:schemeClr val="tx1"/>
-                </a:solidFill>
-              </a:rPr>
-              <a:t>← completion</a:t>
+              <a:t>barrier</a:t>
             </a:r>
           </a:p>
         </p:txBody>
       </p:sp>
       <p:sp>
         <p:nvSpPr>
-          <p:cNvPr id="132" name="legc"/>
-          <p:cNvSpPr txBox="1"/>
+          <p:cNvPr id="122" name="C2 Control"/>
+          <p:cNvSpPr/>
           <p:nvPr/>
         </p:nvSpPr>
         <p:spPr>
           <a:xfrm>
-            <a:off x="3520440" y="3840480"/>
-            <a:ext cx="2103120" cy="137160"/>
-          </a:xfrm>
-          <a:prstGeom prst="rect">
-            <a:avLst/>
-          </a:prstGeom>
-          <a:noFill/>
-        </p:spPr>
-        <p:txBody>
-          <a:bodyPr wrap="square" lIns="0" tIns="0" rIns="0" bIns="0" rtlCol="0" anchor="ctr">
-            <a:noAutofit/>
-          </a:bodyPr>
-          <a:lstStyle/>
-          <a:p>
-            <a:pPr algn="l"/>
-            <a:r>
-              <a:rPr lang="ko-KR" altLang="en-US" sz="600" dirty="0">
-                <a:solidFill>
-                  <a:schemeClr val="tx1"/>
-                </a:solidFill>
-              </a:rPr>
-              <a:t>(plane 색: 노랑 EngineCore, 연두 Worker)</a:t>
-            </a:r>
-          </a:p>
-        </p:txBody>
-      </p:sp>
-      <p:sp>
-        <p:nvSpPr>
-          <p:cNvPr id="133" name="band"/>
-          <p:cNvSpPr/>
-          <p:nvPr/>
-        </p:nvSpPr>
-        <p:spPr>
-          <a:xfrm>
-            <a:off x="6217920" y="1645920"/>
-            <a:ext cx="5303520" cy="594360"/>
+            <a:off x="6217920" y="1627632"/>
+            <a:ext cx="1874520" cy="1874520"/>
           </a:xfrm>
           <a:prstGeom prst="rect">
             <a:avLst/>
@@ -17640,26 +17083,85 @@
           <a:p>
             <a:pPr algn="ctr"/>
             <a:r>
-              <a:rPr lang="ko-KR" altLang="en-US" sz="800" b="1" dirty="0">
+              <a:rPr lang="ko-KR" altLang="en-US" sz="850" b="1" dirty="0">
                 <a:solidFill>
                   <a:schemeClr val="tx1"/>
                 </a:solidFill>
               </a:rPr>
-              <a:t>Serving Engine (기존) + DP1</a:t>
+              <a:t>Control Plane (EngineCore)</a:t>
             </a:r>
           </a:p>
         </p:txBody>
       </p:sp>
       <p:sp>
         <p:nvSpPr>
-          <p:cNvPr id="134" name="DP1 Decision Plane"/>
+          <p:cNvPr id="123" name="C2 Data"/>
           <p:cNvSpPr/>
           <p:nvPr/>
         </p:nvSpPr>
         <p:spPr>
           <a:xfrm>
-            <a:off x="6327648" y="1901952"/>
-            <a:ext cx="1188720" cy="274320"/>
+            <a:off x="9052560" y="1627632"/>
+            <a:ext cx="2834640" cy="1874520"/>
+          </a:xfrm>
+          <a:prstGeom prst="rect">
+            <a:avLst/>
+          </a:prstGeom>
+          <a:solidFill>
+            <a:schemeClr val="bg1">
+              <a:lumMod val="95000"/>
+            </a:schemeClr>
+          </a:solidFill>
+          <a:ln w="19050">
+            <a:solidFill>
+              <a:schemeClr val="tx1"/>
+            </a:solidFill>
+          </a:ln>
+        </p:spPr>
+        <p:style>
+          <a:lnRef idx="2">
+            <a:schemeClr val="accent1">
+              <a:shade val="50000"/>
+            </a:schemeClr>
+          </a:lnRef>
+          <a:fillRef idx="1">
+            <a:schemeClr val="accent1"/>
+          </a:fillRef>
+          <a:effectRef idx="0">
+            <a:schemeClr val="accent1"/>
+          </a:effectRef>
+          <a:fontRef idx="minor">
+            <a:schemeClr val="lt1"/>
+          </a:fontRef>
+        </p:style>
+        <p:txBody>
+          <a:bodyPr lIns="36000" tIns="18000" rIns="36000" bIns="0" rtlCol="0" anchor="t">
+            <a:noAutofit/>
+          </a:bodyPr>
+          <a:lstStyle/>
+          <a:p>
+            <a:pPr algn="ctr"/>
+            <a:r>
+              <a:rPr lang="ko-KR" altLang="en-US" sz="850" b="1" dirty="0">
+                <a:solidFill>
+                  <a:schemeClr val="tx1"/>
+                </a:solidFill>
+              </a:rPr>
+              <a:t>Data Plane (Worker)</a:t>
+            </a:r>
+          </a:p>
+        </p:txBody>
+      </p:sp>
+      <p:sp>
+        <p:nvSpPr>
+          <p:cNvPr id="124" name="Migration Coordinator"/>
+          <p:cNvSpPr/>
+          <p:nvPr/>
+        </p:nvSpPr>
+        <p:spPr>
+          <a:xfrm>
+            <a:off x="6309360" y="1920240"/>
+            <a:ext cx="1691640" cy="329184"/>
           </a:xfrm>
           <a:prstGeom prst="rect">
             <a:avLst/>
@@ -17705,482 +17207,32 @@
                   <a:schemeClr val="tx1"/>
                 </a:solidFill>
               </a:rPr>
-              <a:t>DP1 Decision Plane</a:t>
+              <a:t>Migration Coordinator</a:t>
+            </a:r>
+          </a:p>
+          <a:p>
+            <a:pPr algn="ctr"/>
+            <a:r>
+              <a:rPr lang="ko-KR" altLang="en-US" sz="750" dirty="0">
+                <a:solidFill>
+                  <a:schemeClr val="tx1"/>
+                </a:solidFill>
+              </a:rPr>
+              <a:t>job 1개 중재</a:t>
             </a:r>
           </a:p>
         </p:txBody>
       </p:sp>
       <p:sp>
         <p:nvSpPr>
-          <p:cNvPr id="135" name="Scheduler"/>
+          <p:cNvPr id="125" name="Location Mirror"/>
           <p:cNvSpPr/>
           <p:nvPr/>
         </p:nvSpPr>
         <p:spPr>
           <a:xfrm>
-            <a:off x="7635240" y="1901952"/>
-            <a:ext cx="868680" cy="274320"/>
-          </a:xfrm>
-          <a:prstGeom prst="rect">
-            <a:avLst/>
-          </a:prstGeom>
-          <a:solidFill>
-            <a:schemeClr val="bg1">
-              <a:lumMod val="95000"/>
-            </a:schemeClr>
-          </a:solidFill>
-          <a:ln w="12700">
-            <a:solidFill>
-              <a:schemeClr val="tx1"/>
-            </a:solidFill>
-          </a:ln>
-        </p:spPr>
-        <p:style>
-          <a:lnRef idx="2">
-            <a:schemeClr val="accent1">
-              <a:shade val="50000"/>
-            </a:schemeClr>
-          </a:lnRef>
-          <a:fillRef idx="1">
-            <a:schemeClr val="accent1"/>
-          </a:fillRef>
-          <a:effectRef idx="0">
-            <a:schemeClr val="accent1"/>
-          </a:effectRef>
-          <a:fontRef idx="minor">
-            <a:schemeClr val="lt1"/>
-          </a:fontRef>
-        </p:style>
-        <p:txBody>
-          <a:bodyPr lIns="36000" tIns="18000" rIns="36000" bIns="18000" rtlCol="0" anchor="ctr">
-            <a:noAutofit/>
-          </a:bodyPr>
-          <a:lstStyle/>
-          <a:p>
-            <a:pPr algn="ctr"/>
-            <a:r>
-              <a:rPr lang="ko-KR" altLang="en-US" sz="900" b="1" dirty="0">
-                <a:solidFill>
-                  <a:schemeClr val="tx1"/>
-                </a:solidFill>
-              </a:rPr>
-              <a:t>Scheduler</a:t>
-            </a:r>
-          </a:p>
-        </p:txBody>
-      </p:sp>
-      <p:sp>
-        <p:nvSpPr>
-          <p:cNvPr id="136" name="KVDataAdapter"/>
-          <p:cNvSpPr/>
-          <p:nvPr/>
-        </p:nvSpPr>
-        <p:spPr>
-          <a:xfrm>
-            <a:off x="8595360" y="1901952"/>
-            <a:ext cx="1051560" cy="274320"/>
-          </a:xfrm>
-          <a:prstGeom prst="rect">
-            <a:avLst/>
-          </a:prstGeom>
-          <a:solidFill>
-            <a:schemeClr val="bg1">
-              <a:lumMod val="95000"/>
-            </a:schemeClr>
-          </a:solidFill>
-          <a:ln w="12700">
-            <a:solidFill>
-              <a:schemeClr val="tx1"/>
-            </a:solidFill>
-          </a:ln>
-        </p:spPr>
-        <p:style>
-          <a:lnRef idx="2">
-            <a:schemeClr val="accent1">
-              <a:shade val="50000"/>
-            </a:schemeClr>
-          </a:lnRef>
-          <a:fillRef idx="1">
-            <a:schemeClr val="accent1"/>
-          </a:fillRef>
-          <a:effectRef idx="0">
-            <a:schemeClr val="accent1"/>
-          </a:effectRef>
-          <a:fontRef idx="minor">
-            <a:schemeClr val="lt1"/>
-          </a:fontRef>
-        </p:style>
-        <p:txBody>
-          <a:bodyPr lIns="36000" tIns="18000" rIns="36000" bIns="18000" rtlCol="0" anchor="ctr">
-            <a:noAutofit/>
-          </a:bodyPr>
-          <a:lstStyle/>
-          <a:p>
-            <a:pPr algn="ctr"/>
-            <a:r>
-              <a:rPr lang="ko-KR" altLang="en-US" sz="900" b="1" dirty="0">
-                <a:solidFill>
-                  <a:schemeClr val="tx1"/>
-                </a:solidFill>
-              </a:rPr>
-              <a:t>KVDataAdapter</a:t>
-            </a:r>
-          </a:p>
-        </p:txBody>
-      </p:sp>
-      <p:sp>
-        <p:nvSpPr>
-          <p:cNvPr id="137" name="Block Table"/>
-          <p:cNvSpPr/>
-          <p:nvPr/>
-        </p:nvSpPr>
-        <p:spPr>
-          <a:xfrm>
-            <a:off x="9738360" y="1901952"/>
-            <a:ext cx="777240" cy="274320"/>
-          </a:xfrm>
-          <a:prstGeom prst="rect">
-            <a:avLst/>
-          </a:prstGeom>
-          <a:solidFill>
-            <a:schemeClr val="bg1">
-              <a:lumMod val="95000"/>
-            </a:schemeClr>
-          </a:solidFill>
-          <a:ln w="12700">
-            <a:solidFill>
-              <a:schemeClr val="tx1"/>
-            </a:solidFill>
-          </a:ln>
-        </p:spPr>
-        <p:style>
-          <a:lnRef idx="2">
-            <a:schemeClr val="accent1">
-              <a:shade val="50000"/>
-            </a:schemeClr>
-          </a:lnRef>
-          <a:fillRef idx="1">
-            <a:schemeClr val="accent1"/>
-          </a:fillRef>
-          <a:effectRef idx="0">
-            <a:schemeClr val="accent1"/>
-          </a:effectRef>
-          <a:fontRef idx="minor">
-            <a:schemeClr val="lt1"/>
-          </a:fontRef>
-        </p:style>
-        <p:txBody>
-          <a:bodyPr lIns="36000" tIns="18000" rIns="36000" bIns="18000" rtlCol="0" anchor="ctr">
-            <a:noAutofit/>
-          </a:bodyPr>
-          <a:lstStyle/>
-          <a:p>
-            <a:pPr algn="ctr"/>
-            <a:r>
-              <a:rPr lang="ko-KR" altLang="en-US" sz="900" b="1" dirty="0">
-                <a:solidFill>
-                  <a:schemeClr val="tx1"/>
-                </a:solidFill>
-              </a:rPr>
-              <a:t>Block Table</a:t>
-            </a:r>
-          </a:p>
-        </p:txBody>
-      </p:sp>
-      <p:sp>
-        <p:nvSpPr>
-          <p:cNvPr id="138" name="Model Runner"/>
-          <p:cNvSpPr/>
-          <p:nvPr/>
-        </p:nvSpPr>
-        <p:spPr>
-          <a:xfrm>
-            <a:off x="10607040" y="1901952"/>
-            <a:ext cx="822960" cy="274320"/>
-          </a:xfrm>
-          <a:prstGeom prst="rect">
-            <a:avLst/>
-          </a:prstGeom>
-          <a:solidFill>
-            <a:schemeClr val="accent6">
-              <a:lumMod val="20000"/>
-              <a:lumOff val="80000"/>
-            </a:schemeClr>
-          </a:solidFill>
-          <a:ln w="12700">
-            <a:solidFill>
-              <a:schemeClr val="tx1"/>
-            </a:solidFill>
-          </a:ln>
-        </p:spPr>
-        <p:style>
-          <a:lnRef idx="2">
-            <a:schemeClr val="accent1">
-              <a:shade val="50000"/>
-            </a:schemeClr>
-          </a:lnRef>
-          <a:fillRef idx="1">
-            <a:schemeClr val="accent1"/>
-          </a:fillRef>
-          <a:effectRef idx="0">
-            <a:schemeClr val="accent1"/>
-          </a:effectRef>
-          <a:fontRef idx="minor">
-            <a:schemeClr val="lt1"/>
-          </a:fontRef>
-        </p:style>
-        <p:txBody>
-          <a:bodyPr lIns="36000" tIns="18000" rIns="36000" bIns="18000" rtlCol="0" anchor="ctr">
-            <a:noAutofit/>
-          </a:bodyPr>
-          <a:lstStyle/>
-          <a:p>
-            <a:pPr algn="ctr"/>
-            <a:r>
-              <a:rPr lang="ko-KR" altLang="en-US" sz="900" b="1" dirty="0">
-                <a:solidFill>
-                  <a:schemeClr val="tx1"/>
-                </a:solidFill>
-              </a:rPr>
-              <a:t>Model Runner</a:t>
-            </a:r>
-          </a:p>
-        </p:txBody>
-      </p:sp>
-      <p:sp>
-        <p:nvSpPr>
-          <p:cNvPr id="139" name="Control Plane"/>
-          <p:cNvSpPr/>
-          <p:nvPr/>
-        </p:nvSpPr>
-        <p:spPr>
-          <a:xfrm>
-            <a:off x="6217920" y="2450592"/>
-            <a:ext cx="3566160" cy="1709928"/>
-          </a:xfrm>
-          <a:prstGeom prst="rect">
-            <a:avLst/>
-          </a:prstGeom>
-          <a:solidFill>
-            <a:schemeClr val="accent5">
-              <a:lumMod val="20000"/>
-              <a:lumOff val="80000"/>
-            </a:schemeClr>
-          </a:solidFill>
-          <a:ln w="19050">
-            <a:solidFill>
-              <a:schemeClr val="tx1"/>
-            </a:solidFill>
-          </a:ln>
-        </p:spPr>
-        <p:style>
-          <a:lnRef idx="2">
-            <a:schemeClr val="accent1">
-              <a:shade val="50000"/>
-            </a:schemeClr>
-          </a:lnRef>
-          <a:fillRef idx="1">
-            <a:schemeClr val="accent1"/>
-          </a:fillRef>
-          <a:effectRef idx="0">
-            <a:schemeClr val="accent1"/>
-          </a:effectRef>
-          <a:fontRef idx="minor">
-            <a:schemeClr val="lt1"/>
-          </a:fontRef>
-        </p:style>
-        <p:txBody>
-          <a:bodyPr lIns="36000" tIns="18000" rIns="36000" bIns="0" rtlCol="0" anchor="t">
-            <a:noAutofit/>
-          </a:bodyPr>
-          <a:lstStyle/>
-          <a:p>
-            <a:pPr algn="ctr"/>
-            <a:r>
-              <a:rPr lang="ko-KR" altLang="en-US" sz="850" b="1" dirty="0">
-                <a:solidFill>
-                  <a:schemeClr val="tx1"/>
-                </a:solidFill>
-              </a:rPr>
-              <a:t>Control Plane</a:t>
-            </a:r>
-          </a:p>
-        </p:txBody>
-      </p:sp>
-      <p:sp>
-        <p:nvSpPr>
-          <p:cNvPr id="140" name="Control Plane tab"/>
-          <p:cNvSpPr/>
-          <p:nvPr/>
-        </p:nvSpPr>
-        <p:spPr>
-          <a:xfrm>
-            <a:off x="6217920" y="2331720"/>
-            <a:ext cx="241402" cy="119786"/>
-          </a:xfrm>
-          <a:prstGeom prst="rect">
-            <a:avLst/>
-          </a:prstGeom>
-          <a:solidFill>
-            <a:schemeClr val="accent5">
-              <a:lumMod val="20000"/>
-              <a:lumOff val="80000"/>
-            </a:schemeClr>
-          </a:solidFill>
-          <a:ln w="19050">
-            <a:solidFill>
-              <a:schemeClr val="tx1"/>
-            </a:solidFill>
-          </a:ln>
-        </p:spPr>
-        <p:style>
-          <a:lnRef idx="2">
-            <a:schemeClr val="accent1">
-              <a:shade val="50000"/>
-            </a:schemeClr>
-          </a:lnRef>
-          <a:fillRef idx="1">
-            <a:schemeClr val="accent1"/>
-          </a:fillRef>
-          <a:effectRef idx="0">
-            <a:schemeClr val="accent1"/>
-          </a:effectRef>
-          <a:fontRef idx="minor">
-            <a:schemeClr val="lt1"/>
-          </a:fontRef>
-        </p:style>
-        <p:txBody>
-          <a:bodyPr lIns="36000" tIns="18000" rIns="36000" bIns="18000" rtlCol="0" anchor="ctr">
-            <a:noAutofit/>
-          </a:bodyPr>
-          <a:lstStyle/>
-          <a:p>
-            <a:endParaRPr lang="ko-KR"/>
-          </a:p>
-        </p:txBody>
-      </p:sp>
-      <p:sp>
-        <p:nvSpPr>
-          <p:cNvPr id="141" name="Data Transfer (Worker)"/>
-          <p:cNvSpPr/>
-          <p:nvPr/>
-        </p:nvSpPr>
-        <p:spPr>
-          <a:xfrm>
-            <a:off x="9875520" y="2450592"/>
-            <a:ext cx="1645920" cy="1709928"/>
-          </a:xfrm>
-          <a:prstGeom prst="rect">
-            <a:avLst/>
-          </a:prstGeom>
-          <a:solidFill>
-            <a:schemeClr val="accent5">
-              <a:lumMod val="20000"/>
-              <a:lumOff val="80000"/>
-            </a:schemeClr>
-          </a:solidFill>
-          <a:ln w="19050">
-            <a:solidFill>
-              <a:schemeClr val="tx1"/>
-            </a:solidFill>
-          </a:ln>
-        </p:spPr>
-        <p:style>
-          <a:lnRef idx="2">
-            <a:schemeClr val="accent1">
-              <a:shade val="50000"/>
-            </a:schemeClr>
-          </a:lnRef>
-          <a:fillRef idx="1">
-            <a:schemeClr val="accent1"/>
-          </a:fillRef>
-          <a:effectRef idx="0">
-            <a:schemeClr val="accent1"/>
-          </a:effectRef>
-          <a:fontRef idx="minor">
-            <a:schemeClr val="lt1"/>
-          </a:fontRef>
-        </p:style>
-        <p:txBody>
-          <a:bodyPr lIns="36000" tIns="18000" rIns="36000" bIns="0" rtlCol="0" anchor="t">
-            <a:noAutofit/>
-          </a:bodyPr>
-          <a:lstStyle/>
-          <a:p>
-            <a:pPr algn="ctr"/>
-            <a:r>
-              <a:rPr lang="ko-KR" altLang="en-US" sz="850" b="1" dirty="0">
-                <a:solidFill>
-                  <a:schemeClr val="tx1"/>
-                </a:solidFill>
-              </a:rPr>
-              <a:t>Data Transfer (Worker)</a:t>
-            </a:r>
-          </a:p>
-        </p:txBody>
-      </p:sp>
-      <p:sp>
-        <p:nvSpPr>
-          <p:cNvPr id="142" name="Data Transfer (Worker) tab"/>
-          <p:cNvSpPr/>
-          <p:nvPr/>
-        </p:nvSpPr>
-        <p:spPr>
-          <a:xfrm>
-            <a:off x="9875520" y="2331720"/>
-            <a:ext cx="241402" cy="119786"/>
-          </a:xfrm>
-          <a:prstGeom prst="rect">
-            <a:avLst/>
-          </a:prstGeom>
-          <a:solidFill>
-            <a:schemeClr val="accent5">
-              <a:lumMod val="20000"/>
-              <a:lumOff val="80000"/>
-            </a:schemeClr>
-          </a:solidFill>
-          <a:ln w="19050">
-            <a:solidFill>
-              <a:schemeClr val="tx1"/>
-            </a:solidFill>
-          </a:ln>
-        </p:spPr>
-        <p:style>
-          <a:lnRef idx="2">
-            <a:schemeClr val="accent1">
-              <a:shade val="50000"/>
-            </a:schemeClr>
-          </a:lnRef>
-          <a:fillRef idx="1">
-            <a:schemeClr val="accent1"/>
-          </a:fillRef>
-          <a:effectRef idx="0">
-            <a:schemeClr val="accent1"/>
-          </a:effectRef>
-          <a:fontRef idx="minor">
-            <a:schemeClr val="lt1"/>
-          </a:fontRef>
-        </p:style>
-        <p:txBody>
-          <a:bodyPr lIns="36000" tIns="18000" rIns="36000" bIns="18000" rtlCol="0" anchor="ctr">
-            <a:noAutofit/>
-          </a:bodyPr>
-          <a:lstStyle/>
-          <a:p>
-            <a:endParaRPr lang="ko-KR"/>
-          </a:p>
-        </p:txBody>
-      </p:sp>
-      <p:sp>
-        <p:nvSpPr>
-          <p:cNvPr id="143" name="Migration Coordinator"/>
-          <p:cNvSpPr/>
-          <p:nvPr/>
-        </p:nvSpPr>
-        <p:spPr>
-          <a:xfrm>
-            <a:off x="6309360" y="2724912"/>
-            <a:ext cx="1554480" cy="310896"/>
+            <a:off x="6309360" y="2313432"/>
+            <a:ext cx="1691640" cy="329184"/>
           </a:xfrm>
           <a:prstGeom prst="rect">
             <a:avLst/>
@@ -18226,7 +17278,7 @@
                   <a:schemeClr val="tx1"/>
                 </a:solidFill>
               </a:rPr>
-              <a:t>Migration Coordinator</a:t>
+              <a:t>Location Mirror</a:t>
             </a:r>
           </a:p>
           <a:p>
@@ -18237,21 +17289,21 @@
                   <a:schemeClr val="tx1"/>
                 </a:solidFill>
               </a:rPr>
-              <a:t>(job 1개 중재)</a:t>
+              <a:t>사본, 늦을 수 있음</a:t>
             </a:r>
           </a:p>
         </p:txBody>
       </p:sp>
       <p:sp>
         <p:nvSpPr>
-          <p:cNvPr id="144" name="Location Mirror"/>
+          <p:cNvPr id="126" name="Migration Executor"/>
           <p:cNvSpPr/>
           <p:nvPr/>
         </p:nvSpPr>
         <p:spPr>
           <a:xfrm>
-            <a:off x="6309360" y="3063240"/>
-            <a:ext cx="1554480" cy="310896"/>
+            <a:off x="9144000" y="1920240"/>
+            <a:ext cx="2651760" cy="329184"/>
           </a:xfrm>
           <a:prstGeom prst="rect">
             <a:avLst/>
@@ -18297,7 +17349,7 @@
                   <a:schemeClr val="tx1"/>
                 </a:solidFill>
               </a:rPr>
-              <a:t>Location Mirror</a:t>
+              <a:t>Migration Executor</a:t>
             </a:r>
           </a:p>
           <a:p>
@@ -18308,21 +17360,21 @@
                   <a:schemeClr val="tx1"/>
                 </a:solidFill>
               </a:rPr>
-              <a:t>(사본)</a:t>
+              <a:t>복사 실행</a:t>
             </a:r>
           </a:p>
         </p:txBody>
       </p:sp>
       <p:sp>
         <p:nvSpPr>
-          <p:cNvPr id="145" name="Placement Event Receiver"/>
+          <p:cNvPr id="127" name="Commit Agent"/>
           <p:cNvSpPr/>
           <p:nvPr/>
         </p:nvSpPr>
         <p:spPr>
           <a:xfrm>
-            <a:off x="6309360" y="3401568"/>
-            <a:ext cx="1554480" cy="310896"/>
+            <a:off x="9144000" y="2313432"/>
+            <a:ext cx="2651760" cy="329184"/>
           </a:xfrm>
           <a:prstGeom prst="rect">
             <a:avLst/>
@@ -18368,27 +17420,38 @@
                   <a:schemeClr val="tx1"/>
                 </a:solidFill>
               </a:rPr>
-              <a:t>Placement Event Receiver</a:t>
+              <a:t>Commit Agent</a:t>
+            </a:r>
+          </a:p>
+          <a:p>
+            <a:pPr algn="ctr"/>
+            <a:r>
+              <a:rPr lang="ko-KR" altLang="en-US" sz="750" dirty="0">
+                <a:solidFill>
+                  <a:schemeClr val="tx1"/>
+                </a:solidFill>
+              </a:rPr>
+              <a:t>복사 직후 flip 등록 → 다음 step 시작에 CAS</a:t>
             </a:r>
           </a:p>
         </p:txBody>
       </p:sp>
       <p:sp>
         <p:nvSpPr>
-          <p:cNvPr id="146" name="Commit Agent"/>
+          <p:cNvPr id="128" name="Local Mapping Table"/>
           <p:cNvSpPr/>
           <p:nvPr/>
         </p:nvSpPr>
         <p:spPr>
           <a:xfrm>
-            <a:off x="8046720" y="2724912"/>
-            <a:ext cx="1645920" cy="310896"/>
+            <a:off x="9144000" y="2706624"/>
+            <a:ext cx="2651760" cy="329184"/>
           </a:xfrm>
           <a:prstGeom prst="rect">
             <a:avLst/>
           </a:prstGeom>
           <a:solidFill>
-            <a:schemeClr val="accent6">
+            <a:schemeClr val="accent4">
               <a:lumMod val="20000"/>
               <a:lumOff val="80000"/>
             </a:schemeClr>
@@ -18428,7 +17491,7 @@
                   <a:schemeClr val="tx1"/>
                 </a:solidFill>
               </a:rPr>
-              <a:t>Commit Agent</a:t>
+              <a:t>Local Mapping Table</a:t>
             </a:r>
           </a:p>
           <a:p>
@@ -18439,27 +17502,27 @@
                   <a:schemeClr val="tx1"/>
                 </a:solidFill>
               </a:rPr>
-              <a:t>(flip, version CAS)</a:t>
+              <a:t>(authoritative, version)</a:t>
             </a:r>
           </a:p>
         </p:txBody>
       </p:sp>
       <p:sp>
         <p:nvSpPr>
-          <p:cNvPr id="147" name="Local Mapping Table"/>
+          <p:cNvPr id="129" name="Model Runner"/>
           <p:cNvSpPr/>
           <p:nvPr/>
         </p:nvSpPr>
         <p:spPr>
           <a:xfrm>
-            <a:off x="8046720" y="3063240"/>
-            <a:ext cx="1645920" cy="310896"/>
+            <a:off x="9144000" y="3099816"/>
+            <a:ext cx="1280160" cy="329184"/>
           </a:xfrm>
           <a:prstGeom prst="rect">
             <a:avLst/>
           </a:prstGeom>
           <a:solidFill>
-            <a:schemeClr val="accent6">
+            <a:schemeClr val="accent4">
               <a:lumMod val="20000"/>
               <a:lumOff val="80000"/>
             </a:schemeClr>
@@ -18499,7 +17562,7 @@
                   <a:schemeClr val="tx1"/>
                 </a:solidFill>
               </a:rPr>
-              <a:t>Local Mapping Table</a:t>
+              <a:t>Model Runner</a:t>
             </a:r>
           </a:p>
           <a:p>
@@ -18510,27 +17573,27 @@
                   <a:schemeClr val="tx1"/>
                 </a:solidFill>
               </a:rPr>
-              <a:t>(authoritative)</a:t>
+              <a:t>flip 적용, lease</a:t>
             </a:r>
           </a:p>
         </p:txBody>
       </p:sp>
       <p:sp>
         <p:nvSpPr>
-          <p:cNvPr id="148" name="Lease Manager"/>
+          <p:cNvPr id="130" name="Lease Manager"/>
           <p:cNvSpPr/>
           <p:nvPr/>
         </p:nvSpPr>
         <p:spPr>
           <a:xfrm>
-            <a:off x="8046720" y="3401568"/>
-            <a:ext cx="1645920" cy="310896"/>
+            <a:off x="10515600" y="3099816"/>
+            <a:ext cx="1280160" cy="329184"/>
           </a:xfrm>
           <a:prstGeom prst="rect">
             <a:avLst/>
           </a:prstGeom>
           <a:solidFill>
-            <a:schemeClr val="accent6">
+            <a:schemeClr val="accent4">
               <a:lumMod val="20000"/>
               <a:lumOff val="80000"/>
             </a:schemeClr>
@@ -18581,35 +17644,294 @@
                   <a:schemeClr val="tx1"/>
                 </a:solidFill>
               </a:rPr>
-              <a:t>(step epoch)</a:t>
+              <a:t>step 단위 보호</a:t>
+            </a:r>
+          </a:p>
+        </p:txBody>
+      </p:sp>
+      <p:cxnSp>
+        <p:nvCxnSpPr>
+          <p:cNvPr id="131" name="command"/>
+          <p:cNvCxnSpPr/>
+          <p:nvPr/>
+        </p:nvCxnSpPr>
+        <p:spPr>
+          <a:xfrm>
+            <a:off x="8001000" y="2029968"/>
+            <a:ext cx="1143000" cy="0"/>
+          </a:xfrm>
+          <a:prstGeom prst="line">
+            <a:avLst/>
+          </a:prstGeom>
+          <a:ln w="28575">
+            <a:solidFill>
+              <a:schemeClr val="tx1"/>
+            </a:solidFill>
+            <a:prstDash val="dash"/>
+            <a:tailEnd type="arrow"/>
+          </a:ln>
+        </p:spPr>
+      </p:cxnSp>
+      <p:sp>
+        <p:nvSpPr>
+          <p:cNvPr id="132" name="l1"/>
+          <p:cNvSpPr txBox="1"/>
+          <p:nvPr/>
+        </p:nvSpPr>
+        <p:spPr>
+          <a:xfrm>
+            <a:off x="8001000" y="1828800"/>
+            <a:ext cx="1143000" cy="182880"/>
+          </a:xfrm>
+          <a:prstGeom prst="rect">
+            <a:avLst/>
+          </a:prstGeom>
+          <a:noFill/>
+        </p:spPr>
+        <p:txBody>
+          <a:bodyPr wrap="square" lIns="0" tIns="0" rIns="0" bIns="0" rtlCol="0" anchor="ctr">
+            <a:noAutofit/>
+          </a:bodyPr>
+          <a:lstStyle/>
+          <a:p>
+            <a:pPr algn="ctr"/>
+            <a:r>
+              <a:rPr lang="ko-KR" altLang="en-US" sz="650" b="1" dirty="0">
+                <a:solidFill>
+                  <a:schemeClr val="tx1"/>
+                </a:solidFill>
+              </a:rPr>
+              <a:t>command</a:t>
+            </a:r>
+          </a:p>
+        </p:txBody>
+      </p:sp>
+      <p:cxnSp>
+        <p:nvCxnSpPr>
+          <p:cNvPr id="133" name="event"/>
+          <p:cNvCxnSpPr/>
+          <p:nvPr/>
+        </p:nvCxnSpPr>
+        <p:spPr>
+          <a:xfrm flipH="1">
+            <a:off x="8001000" y="2478024"/>
+            <a:ext cx="1143000" cy="0"/>
+          </a:xfrm>
+          <a:prstGeom prst="line">
+            <a:avLst/>
+          </a:prstGeom>
+          <a:ln w="28575">
+            <a:solidFill>
+              <a:schemeClr val="tx1"/>
+            </a:solidFill>
+            <a:prstDash val="dash"/>
+            <a:tailEnd type="arrow"/>
+          </a:ln>
+        </p:spPr>
+      </p:cxnSp>
+      <p:sp>
+        <p:nvSpPr>
+          <p:cNvPr id="134" name="l2"/>
+          <p:cNvSpPr txBox="1"/>
+          <p:nvPr/>
+        </p:nvSpPr>
+        <p:spPr>
+          <a:xfrm>
+            <a:off x="8046720" y="2505456"/>
+            <a:ext cx="1051560" cy="128016"/>
+          </a:xfrm>
+          <a:prstGeom prst="rect">
+            <a:avLst/>
+          </a:prstGeom>
+          <a:noFill/>
+        </p:spPr>
+        <p:txBody>
+          <a:bodyPr wrap="square" lIns="0" tIns="0" rIns="0" bIns="0" rtlCol="0" anchor="ctr">
+            <a:noAutofit/>
+          </a:bodyPr>
+          <a:lstStyle/>
+          <a:p>
+            <a:pPr algn="ctr"/>
+            <a:r>
+              <a:rPr lang="ko-KR" altLang="en-US" sz="600" b="1" dirty="0">
+                <a:solidFill>
+                  <a:schemeClr val="tx1"/>
+                </a:solidFill>
+              </a:rPr>
+              <a:t>event (비동기)</a:t>
+            </a:r>
+          </a:p>
+        </p:txBody>
+      </p:sp>
+      <p:cxnSp>
+        <p:nvCxnSpPr>
+          <p:cNvPr id="135" name="c1"/>
+          <p:cNvCxnSpPr/>
+          <p:nvPr/>
+        </p:nvCxnSpPr>
+        <p:spPr>
+          <a:xfrm>
+            <a:off x="10469880" y="2249424"/>
+            <a:ext cx="0" cy="64008"/>
+          </a:xfrm>
+          <a:prstGeom prst="line">
+            <a:avLst/>
+          </a:prstGeom>
+          <a:ln w="12700">
+            <a:solidFill>
+              <a:schemeClr val="tx1"/>
+            </a:solidFill>
+            <a:prstDash val="dash"/>
+            <a:tailEnd type="arrow"/>
+          </a:ln>
+        </p:spPr>
+      </p:cxnSp>
+      <p:cxnSp>
+        <p:nvCxnSpPr>
+          <p:cNvPr id="136" name="c2"/>
+          <p:cNvCxnSpPr/>
+          <p:nvPr/>
+        </p:nvCxnSpPr>
+        <p:spPr>
+          <a:xfrm>
+            <a:off x="10469880" y="2642616"/>
+            <a:ext cx="0" cy="64008"/>
+          </a:xfrm>
+          <a:prstGeom prst="line">
+            <a:avLst/>
+          </a:prstGeom>
+          <a:ln w="12700">
+            <a:solidFill>
+              <a:schemeClr val="tx1"/>
+            </a:solidFill>
+            <a:prstDash val="dash"/>
+            <a:tailEnd type="arrow"/>
+          </a:ln>
+        </p:spPr>
+      </p:cxnSp>
+      <p:cxnSp>
+        <p:nvCxnSpPr>
+          <p:cNvPr id="137" name="resolve"/>
+          <p:cNvCxnSpPr/>
+          <p:nvPr/>
+        </p:nvCxnSpPr>
+        <p:spPr>
+          <a:xfrm flipV="1">
+            <a:off x="9784080" y="3035808"/>
+            <a:ext cx="0" cy="64008"/>
+          </a:xfrm>
+          <a:prstGeom prst="line">
+            <a:avLst/>
+          </a:prstGeom>
+          <a:ln w="12700">
+            <a:solidFill>
+              <a:schemeClr val="tx1"/>
+            </a:solidFill>
+            <a:prstDash val="dash"/>
+            <a:tailEnd type="arrow"/>
+          </a:ln>
+        </p:spPr>
+      </p:cxnSp>
+      <p:cxnSp>
+        <p:nvCxnSpPr>
+          <p:cNvPr id="138" name="c3"/>
+          <p:cNvCxnSpPr/>
+          <p:nvPr/>
+        </p:nvCxnSpPr>
+        <p:spPr>
+          <a:xfrm>
+            <a:off x="10424160" y="3264408"/>
+            <a:ext cx="91440" cy="0"/>
+          </a:xfrm>
+          <a:prstGeom prst="line">
+            <a:avLst/>
+          </a:prstGeom>
+          <a:ln w="12700">
+            <a:solidFill>
+              <a:schemeClr val="tx1"/>
+            </a:solidFill>
+            <a:prstDash val="dash"/>
+            <a:headEnd type="arrow"/>
+            <a:tailEnd type="arrow"/>
+          </a:ln>
+        </p:spPr>
+      </p:cxnSp>
+      <p:sp>
+        <p:nvSpPr>
+          <p:cNvPr id="139" name="rs"/>
+          <p:cNvSpPr txBox="1"/>
+          <p:nvPr/>
+        </p:nvSpPr>
+        <p:spPr>
+          <a:xfrm>
+            <a:off x="6309360" y="2724912"/>
+            <a:ext cx="1737360" cy="548640"/>
+          </a:xfrm>
+          <a:prstGeom prst="rect">
+            <a:avLst/>
+          </a:prstGeom>
+          <a:noFill/>
+        </p:spPr>
+        <p:txBody>
+          <a:bodyPr wrap="square" lIns="0" tIns="0" rIns="0" bIns="0" rtlCol="0" anchor="ctr">
+            <a:noAutofit/>
+          </a:bodyPr>
+          <a:lstStyle/>
+          <a:p>
+            <a:pPr algn="l"/>
+            <a:r>
+              <a:rPr lang="ko-KR" altLang="en-US" sz="620" dirty="0">
+                <a:solidFill>
+                  <a:srgbClr val="C00000"/>
+                </a:solidFill>
+              </a:rPr>
+              <a:t>TP&gt;1: Rank Sync가</a:t>
+            </a:r>
+          </a:p>
+          <a:p>
+            <a:pPr algn="l"/>
+            <a:r>
+              <a:rPr lang="ko-KR" altLang="en-US" sz="620" dirty="0">
+                <a:solidFill>
+                  <a:srgbClr val="C00000"/>
+                </a:solidFill>
+              </a:rPr>
+              <a:t>모든 rank의 flip step을</a:t>
+            </a:r>
+          </a:p>
+          <a:p>
+            <a:pPr algn="l"/>
+            <a:r>
+              <a:rPr lang="ko-KR" altLang="en-US" sz="620" dirty="0">
+                <a:solidFill>
+                  <a:srgbClr val="C00000"/>
+                </a:solidFill>
+              </a:rPr>
+              <a:t>합의</a:t>
             </a:r>
           </a:p>
         </p:txBody>
       </p:sp>
       <p:sp>
         <p:nvSpPr>
-          <p:cNvPr id="149" name="Rank Sync"/>
+          <p:cNvPr id="140" name="timeline frame"/>
           <p:cNvSpPr/>
           <p:nvPr/>
         </p:nvSpPr>
         <p:spPr>
           <a:xfrm>
-            <a:off x="8046720" y="3739896"/>
-            <a:ext cx="1645920" cy="310896"/>
+            <a:off x="274320" y="3593592"/>
+            <a:ext cx="5669280" cy="896112"/>
           </a:xfrm>
           <a:prstGeom prst="rect">
             <a:avLst/>
           </a:prstGeom>
-          <a:solidFill>
-            <a:schemeClr val="accent6">
-              <a:lumMod val="20000"/>
-              <a:lumOff val="80000"/>
-            </a:schemeClr>
-          </a:solidFill>
-          <a:ln w="12700">
+          <a:noFill/>
+          <a:ln w="9525">
             <a:solidFill>
-              <a:schemeClr val="tx1"/>
+              <a:srgbClr val="7F7F7F"/>
             </a:solidFill>
+            <a:prstDash val="dash"/>
           </a:ln>
         </p:spPr>
         <p:style>
@@ -18634,53 +17956,165 @@
           </a:bodyPr>
           <a:lstStyle/>
           <a:p>
-            <a:pPr algn="ctr"/>
+            <a:endParaRPr lang="ko-KR"/>
+          </a:p>
+        </p:txBody>
+      </p:sp>
+      <p:sp>
+        <p:nvSpPr>
+          <p:cNvPr id="141" name="tl title"/>
+          <p:cNvSpPr txBox="1"/>
+          <p:nvPr/>
+        </p:nvSpPr>
+        <p:spPr>
+          <a:xfrm>
+            <a:off x="320040" y="3602736"/>
+            <a:ext cx="2743200" cy="128016"/>
+          </a:xfrm>
+          <a:prstGeom prst="rect">
+            <a:avLst/>
+          </a:prstGeom>
+          <a:noFill/>
+        </p:spPr>
+        <p:txBody>
+          <a:bodyPr wrap="square" lIns="0" tIns="0" rIns="0" bIns="0" rtlCol="0" anchor="ctr">
+            <a:noAutofit/>
+          </a:bodyPr>
+          <a:lstStyle/>
+          <a:p>
+            <a:pPr algn="l"/>
             <a:r>
-              <a:rPr lang="ko-KR" altLang="en-US" sz="900" b="1" dirty="0">
+              <a:rPr lang="ko-KR" altLang="en-US" sz="650" b="1" dirty="0">
                 <a:solidFill>
                   <a:schemeClr val="tx1"/>
                 </a:solidFill>
               </a:rPr>
-              <a:t>Rank Sync</a:t>
+              <a:t>commit 타이밍 (step 단위 시간축)</a:t>
             </a:r>
           </a:p>
-          <a:p>
-            <a:pPr algn="ctr"/>
+        </p:txBody>
+      </p:sp>
+      <p:sp>
+        <p:nvSpPr>
+          <p:cNvPr id="142" name="lane ec"/>
+          <p:cNvSpPr txBox="1"/>
+          <p:nvPr/>
+        </p:nvSpPr>
+        <p:spPr>
+          <a:xfrm>
+            <a:off x="320040" y="3867912"/>
+            <a:ext cx="640080" cy="219456"/>
+          </a:xfrm>
+          <a:prstGeom prst="rect">
+            <a:avLst/>
+          </a:prstGeom>
+          <a:noFill/>
+        </p:spPr>
+        <p:txBody>
+          <a:bodyPr wrap="square" lIns="0" tIns="0" rIns="0" bIns="0" rtlCol="0" anchor="ctr">
+            <a:noAutofit/>
+          </a:bodyPr>
+          <a:lstStyle/>
+          <a:p>
+            <a:pPr algn="l"/>
             <a:r>
-              <a:rPr lang="ko-KR" altLang="en-US" sz="750" dirty="0">
+              <a:rPr lang="ko-KR" altLang="en-US" sz="650" b="1" dirty="0">
                 <a:solidFill>
                   <a:schemeClr val="tx1"/>
                 </a:solidFill>
               </a:rPr>
-              <a:t>(TP flip 합의)</a:t>
+              <a:t>EngineCore</a:t>
             </a:r>
           </a:p>
         </p:txBody>
       </p:sp>
       <p:sp>
         <p:nvSpPr>
-          <p:cNvPr id="150" name="Migration Executor"/>
+          <p:cNvPr id="143" name="lane w"/>
+          <p:cNvSpPr txBox="1"/>
+          <p:nvPr/>
+        </p:nvSpPr>
+        <p:spPr>
+          <a:xfrm>
+            <a:off x="320040" y="4160520"/>
+            <a:ext cx="640080" cy="219456"/>
+          </a:xfrm>
+          <a:prstGeom prst="rect">
+            <a:avLst/>
+          </a:prstGeom>
+          <a:noFill/>
+        </p:spPr>
+        <p:txBody>
+          <a:bodyPr wrap="square" lIns="0" tIns="0" rIns="0" bIns="0" rtlCol="0" anchor="ctr">
+            <a:noAutofit/>
+          </a:bodyPr>
+          <a:lstStyle/>
+          <a:p>
+            <a:pPr algn="l"/>
+            <a:r>
+              <a:rPr lang="ko-KR" altLang="en-US" sz="650" b="1" dirty="0">
+                <a:solidFill>
+                  <a:schemeClr val="tx1"/>
+                </a:solidFill>
+              </a:rPr>
+              <a:t>Worker</a:t>
+            </a:r>
+          </a:p>
+        </p:txBody>
+      </p:sp>
+      <p:sp>
+        <p:nvSpPr>
+          <p:cNvPr id="144" name="step"/>
+          <p:cNvSpPr txBox="1"/>
+          <p:nvPr/>
+        </p:nvSpPr>
+        <p:spPr>
+          <a:xfrm>
+            <a:off x="987552" y="3730752"/>
+            <a:ext cx="1371600" cy="118872"/>
+          </a:xfrm>
+          <a:prstGeom prst="rect">
+            <a:avLst/>
+          </a:prstGeom>
+          <a:noFill/>
+        </p:spPr>
+        <p:txBody>
+          <a:bodyPr wrap="square" lIns="0" tIns="0" rIns="0" bIns="0" rtlCol="0" anchor="ctr">
+            <a:noAutofit/>
+          </a:bodyPr>
+          <a:lstStyle/>
+          <a:p>
+            <a:pPr algn="ctr"/>
+            <a:r>
+              <a:rPr lang="ko-KR" altLang="en-US" sz="600" dirty="0">
+                <a:solidFill>
+                  <a:srgbClr val="595959"/>
+                </a:solidFill>
+              </a:rPr>
+              <a:t>step n</a:t>
+            </a:r>
+          </a:p>
+        </p:txBody>
+      </p:sp>
+      <p:sp>
+        <p:nvSpPr>
+          <p:cNvPr id="145" name="ec bar"/>
           <p:cNvSpPr/>
           <p:nvPr/>
         </p:nvSpPr>
         <p:spPr>
           <a:xfrm>
-            <a:off x="9966960" y="2724912"/>
-            <a:ext cx="1463040" cy="310896"/>
+            <a:off x="1005840" y="3867912"/>
+            <a:ext cx="1335024" cy="219456"/>
           </a:xfrm>
           <a:prstGeom prst="rect">
             <a:avLst/>
           </a:prstGeom>
           <a:solidFill>
-            <a:schemeClr val="accent6">
-              <a:lumMod val="20000"/>
-              <a:lumOff val="80000"/>
-            </a:schemeClr>
+            <a:srgbClr val="E7E6E6"/>
           </a:solidFill>
-          <a:ln w="12700">
-            <a:solidFill>
-              <a:schemeClr val="tx1"/>
-            </a:solidFill>
+          <a:ln>
+            <a:noFill/>
           </a:ln>
         </p:spPr>
         <p:style>
@@ -18705,28 +18139,20 @@
           </a:bodyPr>
           <a:lstStyle/>
           <a:p>
-            <a:pPr algn="ctr"/>
-            <a:r>
-              <a:rPr lang="ko-KR" altLang="en-US" sz="900" b="1" dirty="0">
-                <a:solidFill>
-                  <a:schemeClr val="tx1"/>
-                </a:solidFill>
-              </a:rPr>
-              <a:t>Migration Executor</a:t>
-            </a:r>
+            <a:endParaRPr lang="ko-KR"/>
           </a:p>
         </p:txBody>
       </p:sp>
       <p:sp>
         <p:nvSpPr>
-          <p:cNvPr id="151" name="Transfer Router"/>
+          <p:cNvPr id="146" name="w bar"/>
           <p:cNvSpPr/>
           <p:nvPr/>
         </p:nvSpPr>
         <p:spPr>
           <a:xfrm>
-            <a:off x="9966960" y="3063240"/>
-            <a:ext cx="1463040" cy="310896"/>
+            <a:off x="1005840" y="4160520"/>
+            <a:ext cx="1335024" cy="219456"/>
           </a:xfrm>
           <a:prstGeom prst="rect">
             <a:avLst/>
@@ -18737,10 +18163,8 @@
               <a:lumOff val="80000"/>
             </a:schemeClr>
           </a:solidFill>
-          <a:ln w="12700">
-            <a:solidFill>
-              <a:schemeClr val="tx1"/>
-            </a:solidFill>
+          <a:ln>
+            <a:noFill/>
           </a:ln>
         </p:spPr>
         <p:style>
@@ -18765,254 +18189,365 @@
           </a:bodyPr>
           <a:lstStyle/>
           <a:p>
+            <a:endParaRPr lang="ko-KR"/>
+          </a:p>
+        </p:txBody>
+      </p:sp>
+      <p:sp>
+        <p:nvSpPr>
+          <p:cNvPr id="147" name="step"/>
+          <p:cNvSpPr txBox="1"/>
+          <p:nvPr/>
+        </p:nvSpPr>
+        <p:spPr>
+          <a:xfrm>
+            <a:off x="2359152" y="3730752"/>
+            <a:ext cx="1554480" cy="118872"/>
+          </a:xfrm>
+          <a:prstGeom prst="rect">
+            <a:avLst/>
+          </a:prstGeom>
+          <a:noFill/>
+        </p:spPr>
+        <p:txBody>
+          <a:bodyPr wrap="square" lIns="0" tIns="0" rIns="0" bIns="0" rtlCol="0" anchor="ctr">
+            <a:noAutofit/>
+          </a:bodyPr>
+          <a:lstStyle/>
+          <a:p>
             <a:pPr algn="ctr"/>
             <a:r>
-              <a:rPr lang="ko-KR" altLang="en-US" sz="900" b="1" dirty="0">
+              <a:rPr lang="ko-KR" altLang="en-US" sz="600" dirty="0">
                 <a:solidFill>
-                  <a:schemeClr val="tx1"/>
+                  <a:srgbClr val="595959"/>
                 </a:solidFill>
               </a:rPr>
-              <a:t>Transfer Router</a:t>
+              <a:t>step n+1</a:t>
             </a:r>
           </a:p>
         </p:txBody>
       </p:sp>
-      <p:cxnSp>
-        <p:nvCxnSpPr>
-          <p:cNvPr id="152" name="intent"/>
-          <p:cNvCxnSpPr/>
-          <p:nvPr/>
-        </p:nvCxnSpPr>
-        <p:spPr>
-          <a:xfrm>
-            <a:off x="7086600" y="2176272"/>
-            <a:ext cx="0" cy="548640"/>
-          </a:xfrm>
-          <a:prstGeom prst="line">
-            <a:avLst/>
-          </a:prstGeom>
-          <a:ln w="28575">
+      <p:sp>
+        <p:nvSpPr>
+          <p:cNvPr id="148" name="ec bar"/>
+          <p:cNvSpPr/>
+          <p:nvPr/>
+        </p:nvSpPr>
+        <p:spPr>
+          <a:xfrm>
+            <a:off x="2377440" y="3867912"/>
+            <a:ext cx="1517904" cy="219456"/>
+          </a:xfrm>
+          <a:prstGeom prst="rect">
+            <a:avLst/>
+          </a:prstGeom>
+          <a:solidFill>
+            <a:srgbClr val="E7E6E6"/>
+          </a:solidFill>
+          <a:ln>
+            <a:noFill/>
+          </a:ln>
+        </p:spPr>
+        <p:style>
+          <a:lnRef idx="2">
+            <a:schemeClr val="accent1">
+              <a:shade val="50000"/>
+            </a:schemeClr>
+          </a:lnRef>
+          <a:fillRef idx="1">
+            <a:schemeClr val="accent1"/>
+          </a:fillRef>
+          <a:effectRef idx="0">
+            <a:schemeClr val="accent1"/>
+          </a:effectRef>
+          <a:fontRef idx="minor">
+            <a:schemeClr val="lt1"/>
+          </a:fontRef>
+        </p:style>
+        <p:txBody>
+          <a:bodyPr lIns="36000" tIns="18000" rIns="36000" bIns="18000" rtlCol="0" anchor="ctr">
+            <a:noAutofit/>
+          </a:bodyPr>
+          <a:lstStyle/>
+          <a:p>
+            <a:endParaRPr lang="ko-KR"/>
+          </a:p>
+        </p:txBody>
+      </p:sp>
+      <p:sp>
+        <p:nvSpPr>
+          <p:cNvPr id="149" name="w bar"/>
+          <p:cNvSpPr/>
+          <p:nvPr/>
+        </p:nvSpPr>
+        <p:spPr>
+          <a:xfrm>
+            <a:off x="2377440" y="4160520"/>
+            <a:ext cx="1517904" cy="219456"/>
+          </a:xfrm>
+          <a:prstGeom prst="rect">
+            <a:avLst/>
+          </a:prstGeom>
+          <a:solidFill>
+            <a:schemeClr val="accent6">
+              <a:lumMod val="20000"/>
+              <a:lumOff val="80000"/>
+            </a:schemeClr>
+          </a:solidFill>
+          <a:ln>
+            <a:noFill/>
+          </a:ln>
+        </p:spPr>
+        <p:style>
+          <a:lnRef idx="2">
+            <a:schemeClr val="accent1">
+              <a:shade val="50000"/>
+            </a:schemeClr>
+          </a:lnRef>
+          <a:fillRef idx="1">
+            <a:schemeClr val="accent1"/>
+          </a:fillRef>
+          <a:effectRef idx="0">
+            <a:schemeClr val="accent1"/>
+          </a:effectRef>
+          <a:fontRef idx="minor">
+            <a:schemeClr val="lt1"/>
+          </a:fontRef>
+        </p:style>
+        <p:txBody>
+          <a:bodyPr lIns="36000" tIns="18000" rIns="36000" bIns="18000" rtlCol="0" anchor="ctr">
+            <a:noAutofit/>
+          </a:bodyPr>
+          <a:lstStyle/>
+          <a:p>
+            <a:endParaRPr lang="ko-KR"/>
+          </a:p>
+        </p:txBody>
+      </p:sp>
+      <p:sp>
+        <p:nvSpPr>
+          <p:cNvPr id="150" name="step"/>
+          <p:cNvSpPr txBox="1"/>
+          <p:nvPr/>
+        </p:nvSpPr>
+        <p:spPr>
+          <a:xfrm>
+            <a:off x="3913632" y="3730752"/>
+            <a:ext cx="1481328" cy="118872"/>
+          </a:xfrm>
+          <a:prstGeom prst="rect">
+            <a:avLst/>
+          </a:prstGeom>
+          <a:noFill/>
+        </p:spPr>
+        <p:txBody>
+          <a:bodyPr wrap="square" lIns="0" tIns="0" rIns="0" bIns="0" rtlCol="0" anchor="ctr">
+            <a:noAutofit/>
+          </a:bodyPr>
+          <a:lstStyle/>
+          <a:p>
+            <a:pPr algn="ctr"/>
+            <a:r>
+              <a:rPr lang="ko-KR" altLang="en-US" sz="600" dirty="0">
+                <a:solidFill>
+                  <a:srgbClr val="595959"/>
+                </a:solidFill>
+              </a:rPr>
+              <a:t>step n+2</a:t>
+            </a:r>
+          </a:p>
+        </p:txBody>
+      </p:sp>
+      <p:sp>
+        <p:nvSpPr>
+          <p:cNvPr id="151" name="ec bar"/>
+          <p:cNvSpPr/>
+          <p:nvPr/>
+        </p:nvSpPr>
+        <p:spPr>
+          <a:xfrm>
+            <a:off x="3931920" y="3867912"/>
+            <a:ext cx="1444752" cy="219456"/>
+          </a:xfrm>
+          <a:prstGeom prst="rect">
+            <a:avLst/>
+          </a:prstGeom>
+          <a:solidFill>
+            <a:srgbClr val="E7E6E6"/>
+          </a:solidFill>
+          <a:ln>
+            <a:noFill/>
+          </a:ln>
+        </p:spPr>
+        <p:style>
+          <a:lnRef idx="2">
+            <a:schemeClr val="accent1">
+              <a:shade val="50000"/>
+            </a:schemeClr>
+          </a:lnRef>
+          <a:fillRef idx="1">
+            <a:schemeClr val="accent1"/>
+          </a:fillRef>
+          <a:effectRef idx="0">
+            <a:schemeClr val="accent1"/>
+          </a:effectRef>
+          <a:fontRef idx="minor">
+            <a:schemeClr val="lt1"/>
+          </a:fontRef>
+        </p:style>
+        <p:txBody>
+          <a:bodyPr lIns="36000" tIns="18000" rIns="36000" bIns="18000" rtlCol="0" anchor="ctr">
+            <a:noAutofit/>
+          </a:bodyPr>
+          <a:lstStyle/>
+          <a:p>
+            <a:endParaRPr lang="ko-KR"/>
+          </a:p>
+        </p:txBody>
+      </p:sp>
+      <p:sp>
+        <p:nvSpPr>
+          <p:cNvPr id="152" name="w bar"/>
+          <p:cNvSpPr/>
+          <p:nvPr/>
+        </p:nvSpPr>
+        <p:spPr>
+          <a:xfrm>
+            <a:off x="3931920" y="4160520"/>
+            <a:ext cx="1444752" cy="219456"/>
+          </a:xfrm>
+          <a:prstGeom prst="rect">
+            <a:avLst/>
+          </a:prstGeom>
+          <a:solidFill>
+            <a:schemeClr val="accent6">
+              <a:lumMod val="20000"/>
+              <a:lumOff val="80000"/>
+            </a:schemeClr>
+          </a:solidFill>
+          <a:ln>
+            <a:noFill/>
+          </a:ln>
+        </p:spPr>
+        <p:style>
+          <a:lnRef idx="2">
+            <a:schemeClr val="accent1">
+              <a:shade val="50000"/>
+            </a:schemeClr>
+          </a:lnRef>
+          <a:fillRef idx="1">
+            <a:schemeClr val="accent1"/>
+          </a:fillRef>
+          <a:effectRef idx="0">
+            <a:schemeClr val="accent1"/>
+          </a:effectRef>
+          <a:fontRef idx="minor">
+            <a:schemeClr val="lt1"/>
+          </a:fontRef>
+        </p:style>
+        <p:txBody>
+          <a:bodyPr lIns="36000" tIns="18000" rIns="36000" bIns="18000" rtlCol="0" anchor="ctr">
+            <a:noAutofit/>
+          </a:bodyPr>
+          <a:lstStyle/>
+          <a:p>
+            <a:endParaRPr lang="ko-KR"/>
+          </a:p>
+        </p:txBody>
+      </p:sp>
+      <p:sp>
+        <p:nvSpPr>
+          <p:cNvPr id="153" name="l"/>
+          <p:cNvSpPr txBox="1"/>
+          <p:nvPr/>
+        </p:nvSpPr>
+        <p:spPr>
+          <a:xfrm>
+            <a:off x="1033272" y="3886200"/>
+            <a:ext cx="1280160" cy="182880"/>
+          </a:xfrm>
+          <a:prstGeom prst="rect">
+            <a:avLst/>
+          </a:prstGeom>
+          <a:noFill/>
+        </p:spPr>
+        <p:txBody>
+          <a:bodyPr wrap="square" lIns="0" tIns="0" rIns="0" bIns="0" rtlCol="0" anchor="ctr">
+            <a:noAutofit/>
+          </a:bodyPr>
+          <a:lstStyle/>
+          <a:p>
+            <a:pPr algn="l"/>
+            <a:r>
+              <a:rPr lang="ko-KR" altLang="en-US" sz="600" dirty="0">
+                <a:solidFill>
+                  <a:srgbClr val="595959"/>
+                </a:solidFill>
+              </a:rPr>
+              <a:t>schedule → execute 대기</a:t>
+            </a:r>
+          </a:p>
+        </p:txBody>
+      </p:sp>
+      <p:sp>
+        <p:nvSpPr>
+          <p:cNvPr id="154" name="copy done"/>
+          <p:cNvSpPr/>
+          <p:nvPr/>
+        </p:nvSpPr>
+        <p:spPr>
+          <a:xfrm>
+            <a:off x="2153412" y="4201668"/>
+            <a:ext cx="137160" cy="137160"/>
+          </a:xfrm>
+          <a:prstGeom prst="ellipse">
+            <a:avLst/>
+          </a:prstGeom>
+          <a:solidFill>
+            <a:schemeClr val="tx1"/>
+          </a:solidFill>
+          <a:ln w="9525">
             <a:solidFill>
               <a:schemeClr val="tx1"/>
             </a:solidFill>
-            <a:prstDash val="dash"/>
-            <a:tailEnd type="arrow"/>
           </a:ln>
         </p:spPr>
-      </p:cxnSp>
-      <p:sp>
-        <p:nvSpPr>
-          <p:cNvPr id="153" name="command"/>
-          <p:cNvSpPr/>
-          <p:nvPr/>
-        </p:nvSpPr>
-        <p:spPr>
-          <a:xfrm>
-            <a:off x="6583680" y="2295144"/>
-            <a:ext cx="4114800" cy="429768"/>
-          </a:xfrm>
-          <a:custGeom>
-            <a:avLst/>
-            <a:gdLst/>
-            <a:ahLst/>
-            <a:cxnLst/>
-            <a:rect l="0" t="0" r="r" b="b"/>
-            <a:pathLst>
-              <a:path w="4114800" h="429768" fill="none">
-                <a:moveTo>
-                  <a:pt x="0" y="429768"/>
-                </a:moveTo>
-                <a:lnTo>
-                  <a:pt x="0" y="0"/>
-                </a:lnTo>
-                <a:lnTo>
-                  <a:pt x="4114800" y="0"/>
-                </a:lnTo>
-                <a:lnTo>
-                  <a:pt x="4114800" y="429768"/>
-                </a:lnTo>
-              </a:path>
-            </a:pathLst>
-          </a:custGeom>
-          <a:noFill/>
-          <a:ln w="28575">
-            <a:solidFill>
-              <a:schemeClr val="tx1"/>
-            </a:solidFill>
-            <a:prstDash val="dash"/>
-            <a:tailEnd type="arrow"/>
-          </a:ln>
-        </p:spPr>
-      </p:sp>
-      <p:cxnSp>
-        <p:nvCxnSpPr>
-          <p:cNvPr id="154" name="copy done"/>
-          <p:cNvCxnSpPr/>
-          <p:nvPr/>
-        </p:nvCxnSpPr>
-        <p:spPr>
-          <a:xfrm flipH="1">
-            <a:off x="9692640" y="2880360"/>
-            <a:ext cx="274320" cy="0"/>
-          </a:xfrm>
-          <a:prstGeom prst="line">
-            <a:avLst/>
-          </a:prstGeom>
-          <a:ln w="12700">
-            <a:solidFill>
-              <a:schemeClr val="tx1"/>
-            </a:solidFill>
-            <a:prstDash val="dash"/>
-            <a:tailEnd type="arrow"/>
-          </a:ln>
-        </p:spPr>
-      </p:cxnSp>
-      <p:cxnSp>
-        <p:nvCxnSpPr>
-          <p:cNvPr id="155" name="c1"/>
-          <p:cNvCxnSpPr/>
-          <p:nvPr/>
-        </p:nvCxnSpPr>
-        <p:spPr>
-          <a:xfrm>
-            <a:off x="8869680" y="3035808"/>
-            <a:ext cx="0" cy="27432"/>
-          </a:xfrm>
-          <a:prstGeom prst="line">
-            <a:avLst/>
-          </a:prstGeom>
-          <a:ln w="12700">
-            <a:solidFill>
-              <a:schemeClr val="tx1"/>
-            </a:solidFill>
-            <a:prstDash val="dash"/>
-            <a:tailEnd type="arrow"/>
-          </a:ln>
-        </p:spPr>
-      </p:cxnSp>
-      <p:cxnSp>
-        <p:nvCxnSpPr>
-          <p:cNvPr id="156" name="c2"/>
-          <p:cNvCxnSpPr/>
-          <p:nvPr/>
-        </p:nvCxnSpPr>
-        <p:spPr>
-          <a:xfrm>
-            <a:off x="10698480" y="3035808"/>
-            <a:ext cx="0" cy="27432"/>
-          </a:xfrm>
-          <a:prstGeom prst="line">
-            <a:avLst/>
-          </a:prstGeom>
-          <a:ln w="12700">
-            <a:solidFill>
-              <a:schemeClr val="tx1"/>
-            </a:solidFill>
-            <a:prstDash val="dash"/>
-            <a:tailEnd type="arrow"/>
-          </a:ln>
-        </p:spPr>
-      </p:cxnSp>
-      <p:cxnSp>
-        <p:nvCxnSpPr>
-          <p:cNvPr id="157" name="c3"/>
-          <p:cNvCxnSpPr/>
-          <p:nvPr/>
-        </p:nvCxnSpPr>
-        <p:spPr>
-          <a:xfrm flipV="1">
-            <a:off x="8869680" y="3712464"/>
-            <a:ext cx="0" cy="27432"/>
-          </a:xfrm>
-          <a:prstGeom prst="line">
-            <a:avLst/>
-          </a:prstGeom>
-          <a:ln w="12700">
-            <a:solidFill>
-              <a:schemeClr val="tx1"/>
-            </a:solidFill>
-            <a:prstDash val="dash"/>
-            <a:tailEnd type="arrow"/>
-          </a:ln>
-        </p:spPr>
-      </p:cxnSp>
-      <p:cxnSp>
-        <p:nvCxnSpPr>
-          <p:cNvPr id="158" name="c4"/>
-          <p:cNvCxnSpPr/>
-          <p:nvPr/>
-        </p:nvCxnSpPr>
-        <p:spPr>
-          <a:xfrm flipV="1">
-            <a:off x="7086600" y="3374136"/>
-            <a:ext cx="0" cy="27432"/>
-          </a:xfrm>
-          <a:prstGeom prst="line">
-            <a:avLst/>
-          </a:prstGeom>
-          <a:ln w="12700">
-            <a:solidFill>
-              <a:schemeClr val="tx1"/>
-            </a:solidFill>
-            <a:prstDash val="dash"/>
-            <a:tailEnd type="arrow"/>
-          </a:ln>
-        </p:spPr>
-      </p:cxnSp>
-      <p:sp>
-        <p:nvSpPr>
-          <p:cNvPr id="159" name="event"/>
-          <p:cNvSpPr/>
-          <p:nvPr/>
-        </p:nvSpPr>
-        <p:spPr>
-          <a:xfrm>
-            <a:off x="7863840" y="2980944"/>
-            <a:ext cx="182880" cy="576072"/>
-          </a:xfrm>
-          <a:custGeom>
-            <a:avLst/>
-            <a:gdLst/>
-            <a:ahLst/>
-            <a:cxnLst/>
-            <a:rect l="0" t="0" r="r" b="b"/>
-            <a:pathLst>
-              <a:path w="182880" h="576072" fill="none">
-                <a:moveTo>
-                  <a:pt x="182880" y="0"/>
-                </a:moveTo>
-                <a:lnTo>
-                  <a:pt x="91440" y="0"/>
-                </a:lnTo>
-                <a:lnTo>
-                  <a:pt x="91440" y="576072"/>
-                </a:lnTo>
-                <a:lnTo>
-                  <a:pt x="0" y="576072"/>
-                </a:lnTo>
-              </a:path>
-            </a:pathLst>
-          </a:custGeom>
-          <a:noFill/>
-          <a:ln w="28575">
-            <a:solidFill>
-              <a:schemeClr val="tx1"/>
-            </a:solidFill>
-            <a:prstDash val="dash"/>
-            <a:tailEnd type="arrow"/>
-          </a:ln>
-        </p:spPr>
+        <p:style>
+          <a:lnRef idx="2">
+            <a:schemeClr val="accent1">
+              <a:shade val="50000"/>
+            </a:schemeClr>
+          </a:lnRef>
+          <a:fillRef idx="1">
+            <a:schemeClr val="accent1"/>
+          </a:fillRef>
+          <a:effectRef idx="0">
+            <a:schemeClr val="accent1"/>
+          </a:effectRef>
+          <a:fontRef idx="minor">
+            <a:schemeClr val="lt1"/>
+          </a:fontRef>
+        </p:style>
+        <p:txBody>
+          <a:bodyPr lIns="36000" tIns="18000" rIns="36000" bIns="18000" rtlCol="0" anchor="ctr">
+            <a:noAutofit/>
+          </a:bodyPr>
+          <a:lstStyle/>
+          <a:p>
+            <a:endParaRPr lang="ko-KR"/>
+          </a:p>
+        </p:txBody>
       </p:sp>
       <p:sp>
         <p:nvSpPr>
-          <p:cNvPr id="160" name="legend"/>
+          <p:cNvPr id="155" name="l"/>
           <p:cNvSpPr txBox="1"/>
           <p:nvPr/>
         </p:nvSpPr>
         <p:spPr>
           <a:xfrm>
-            <a:off x="6263640" y="3749040"/>
-            <a:ext cx="1737360" cy="402336"/>
+            <a:off x="1033272" y="4178808"/>
+            <a:ext cx="1143000" cy="182880"/>
           </a:xfrm>
           <a:prstGeom prst="rect">
             <a:avLst/>
@@ -19032,9 +18567,115 @@
                   <a:schemeClr val="tx1"/>
                 </a:solidFill>
               </a:rPr>
-              <a:t>굵은 선: → Intent · command</a:t>
+              <a:t>copy 완료 → 완료 보고</a:t>
             </a:r>
           </a:p>
+        </p:txBody>
+      </p:sp>
+      <p:sp>
+        <p:nvSpPr>
+          <p:cNvPr id="156" name="commit"/>
+          <p:cNvSpPr/>
+          <p:nvPr/>
+        </p:nvSpPr>
+        <p:spPr>
+          <a:xfrm>
+            <a:off x="2400300" y="3909060"/>
+            <a:ext cx="137160" cy="137160"/>
+          </a:xfrm>
+          <a:prstGeom prst="ellipse">
+            <a:avLst/>
+          </a:prstGeom>
+          <a:solidFill>
+            <a:srgbClr val="C00000"/>
+          </a:solidFill>
+          <a:ln w="9525">
+            <a:solidFill>
+              <a:schemeClr val="tx1"/>
+            </a:solidFill>
+          </a:ln>
+        </p:spPr>
+        <p:style>
+          <a:lnRef idx="2">
+            <a:schemeClr val="accent1">
+              <a:shade val="50000"/>
+            </a:schemeClr>
+          </a:lnRef>
+          <a:fillRef idx="1">
+            <a:schemeClr val="accent1"/>
+          </a:fillRef>
+          <a:effectRef idx="0">
+            <a:schemeClr val="accent1"/>
+          </a:effectRef>
+          <a:fontRef idx="minor">
+            <a:schemeClr val="lt1"/>
+          </a:fontRef>
+        </p:style>
+        <p:txBody>
+          <a:bodyPr lIns="36000" tIns="18000" rIns="36000" bIns="18000" rtlCol="0" anchor="ctr">
+            <a:noAutofit/>
+          </a:bodyPr>
+          <a:lstStyle/>
+          <a:p>
+            <a:endParaRPr lang="ko-KR"/>
+          </a:p>
+        </p:txBody>
+      </p:sp>
+      <p:sp>
+        <p:nvSpPr>
+          <p:cNvPr id="157" name="l"/>
+          <p:cNvSpPr txBox="1"/>
+          <p:nvPr/>
+        </p:nvSpPr>
+        <p:spPr>
+          <a:xfrm>
+            <a:off x="2560320" y="3886200"/>
+            <a:ext cx="1280160" cy="182880"/>
+          </a:xfrm>
+          <a:prstGeom prst="rect">
+            <a:avLst/>
+          </a:prstGeom>
+          <a:noFill/>
+        </p:spPr>
+        <p:txBody>
+          <a:bodyPr wrap="square" lIns="0" tIns="0" rIns="0" bIns="0" rtlCol="0" anchor="ctr">
+            <a:noAutofit/>
+          </a:bodyPr>
+          <a:lstStyle/>
+          <a:p>
+            <a:pPr algn="l"/>
+            <a:r>
+              <a:rPr lang="ko-KR" altLang="en-US" sz="600" b="1" dirty="0">
+                <a:solidFill>
+                  <a:srgbClr val="C00000"/>
+                </a:solidFill>
+              </a:rPr>
+              <a:t>다음 schedule() 시작 시 commit</a:t>
+            </a:r>
+          </a:p>
+        </p:txBody>
+      </p:sp>
+      <p:sp>
+        <p:nvSpPr>
+          <p:cNvPr id="158" name="l"/>
+          <p:cNvSpPr txBox="1"/>
+          <p:nvPr/>
+        </p:nvSpPr>
+        <p:spPr>
+          <a:xfrm>
+            <a:off x="2404872" y="4178808"/>
+            <a:ext cx="1463040" cy="182880"/>
+          </a:xfrm>
+          <a:prstGeom prst="rect">
+            <a:avLst/>
+          </a:prstGeom>
+          <a:noFill/>
+        </p:spPr>
+        <p:txBody>
+          <a:bodyPr wrap="square" lIns="0" tIns="0" rIns="0" bIns="0" rtlCol="0" anchor="ctr">
+            <a:noAutofit/>
+          </a:bodyPr>
+          <a:lstStyle/>
           <a:p>
             <a:pPr algn="l"/>
             <a:r>
@@ -19043,9 +18684,741 @@
                   <a:schemeClr val="tx1"/>
                 </a:solidFill>
               </a:rPr>
-              <a:t>← placement event</a:t>
+              <a:t>새 위치 사용 (n+1 ~ n+2)</a:t>
             </a:r>
           </a:p>
+        </p:txBody>
+      </p:sp>
+      <p:cxnSp>
+        <p:nvCxnSpPr>
+          <p:cNvPr id="159" name="ev"/>
+          <p:cNvCxnSpPr/>
+          <p:nvPr/>
+        </p:nvCxnSpPr>
+        <p:spPr>
+          <a:xfrm flipV="1">
+            <a:off x="2221992" y="4041648"/>
+            <a:ext cx="246888" cy="164592"/>
+          </a:xfrm>
+          <a:prstGeom prst="line">
+            <a:avLst/>
+          </a:prstGeom>
+          <a:ln w="9525">
+            <a:solidFill>
+              <a:schemeClr val="tx1"/>
+            </a:solidFill>
+            <a:prstDash val="sysDot"/>
+            <a:tailEnd type="arrow"/>
+          </a:ln>
+        </p:spPr>
+      </p:cxnSp>
+      <p:sp>
+        <p:nvSpPr>
+          <p:cNvPr id="160" name="l"/>
+          <p:cNvSpPr txBox="1"/>
+          <p:nvPr/>
+        </p:nvSpPr>
+        <p:spPr>
+          <a:xfrm>
+            <a:off x="3959352" y="3886200"/>
+            <a:ext cx="1371600" cy="182880"/>
+          </a:xfrm>
+          <a:prstGeom prst="rect">
+            <a:avLst/>
+          </a:prstGeom>
+          <a:noFill/>
+        </p:spPr>
+        <p:txBody>
+          <a:bodyPr wrap="square" lIns="0" tIns="0" rIns="0" bIns="0" rtlCol="0" anchor="ctr">
+            <a:noAutofit/>
+          </a:bodyPr>
+          <a:lstStyle/>
+          <a:p>
+            <a:pPr algn="l"/>
+            <a:r>
+              <a:rPr lang="ko-KR" altLang="en-US" sz="600" dirty="0">
+                <a:solidFill>
+                  <a:srgbClr val="595959"/>
+                </a:solidFill>
+              </a:rPr>
+              <a:t>slot 해제: epoch 소진 후</a:t>
+            </a:r>
+          </a:p>
+        </p:txBody>
+      </p:sp>
+      <p:sp>
+        <p:nvSpPr>
+          <p:cNvPr id="161" name="tl leg"/>
+          <p:cNvSpPr txBox="1"/>
+          <p:nvPr/>
+        </p:nvSpPr>
+        <p:spPr>
+          <a:xfrm>
+            <a:off x="320040" y="4379976"/>
+            <a:ext cx="5303520" cy="100584"/>
+          </a:xfrm>
+          <a:prstGeom prst="rect">
+            <a:avLst/>
+          </a:prstGeom>
+          <a:noFill/>
+        </p:spPr>
+        <p:txBody>
+          <a:bodyPr wrap="square" lIns="0" tIns="0" rIns="0" bIns="0" rtlCol="0" anchor="ctr">
+            <a:noAutofit/>
+          </a:bodyPr>
+          <a:lstStyle/>
+          <a:p>
+            <a:pPr algn="l"/>
+          </a:p>
+        </p:txBody>
+      </p:sp>
+      <p:sp>
+        <p:nvSpPr>
+          <p:cNvPr id="162" name="timeline frame"/>
+          <p:cNvSpPr/>
+          <p:nvPr/>
+        </p:nvSpPr>
+        <p:spPr>
+          <a:xfrm>
+            <a:off x="6217920" y="3593592"/>
+            <a:ext cx="5669280" cy="896112"/>
+          </a:xfrm>
+          <a:prstGeom prst="rect">
+            <a:avLst/>
+          </a:prstGeom>
+          <a:noFill/>
+          <a:ln w="9525">
+            <a:solidFill>
+              <a:srgbClr val="7F7F7F"/>
+            </a:solidFill>
+            <a:prstDash val="dash"/>
+          </a:ln>
+        </p:spPr>
+        <p:style>
+          <a:lnRef idx="2">
+            <a:schemeClr val="accent1">
+              <a:shade val="50000"/>
+            </a:schemeClr>
+          </a:lnRef>
+          <a:fillRef idx="1">
+            <a:schemeClr val="accent1"/>
+          </a:fillRef>
+          <a:effectRef idx="0">
+            <a:schemeClr val="accent1"/>
+          </a:effectRef>
+          <a:fontRef idx="minor">
+            <a:schemeClr val="lt1"/>
+          </a:fontRef>
+        </p:style>
+        <p:txBody>
+          <a:bodyPr lIns="36000" tIns="18000" rIns="36000" bIns="18000" rtlCol="0" anchor="ctr">
+            <a:noAutofit/>
+          </a:bodyPr>
+          <a:lstStyle/>
+          <a:p>
+            <a:endParaRPr lang="ko-KR"/>
+          </a:p>
+        </p:txBody>
+      </p:sp>
+      <p:sp>
+        <p:nvSpPr>
+          <p:cNvPr id="163" name="tl title"/>
+          <p:cNvSpPr txBox="1"/>
+          <p:nvPr/>
+        </p:nvSpPr>
+        <p:spPr>
+          <a:xfrm>
+            <a:off x="6263640" y="3602736"/>
+            <a:ext cx="2743200" cy="128016"/>
+          </a:xfrm>
+          <a:prstGeom prst="rect">
+            <a:avLst/>
+          </a:prstGeom>
+          <a:noFill/>
+        </p:spPr>
+        <p:txBody>
+          <a:bodyPr wrap="square" lIns="0" tIns="0" rIns="0" bIns="0" rtlCol="0" anchor="ctr">
+            <a:noAutofit/>
+          </a:bodyPr>
+          <a:lstStyle/>
+          <a:p>
+            <a:pPr algn="l"/>
+            <a:r>
+              <a:rPr lang="ko-KR" altLang="en-US" sz="650" b="1" dirty="0">
+                <a:solidFill>
+                  <a:schemeClr val="tx1"/>
+                </a:solidFill>
+              </a:rPr>
+              <a:t>commit 타이밍 (step 단위 시간축)</a:t>
+            </a:r>
+          </a:p>
+        </p:txBody>
+      </p:sp>
+      <p:sp>
+        <p:nvSpPr>
+          <p:cNvPr id="164" name="lane ec"/>
+          <p:cNvSpPr txBox="1"/>
+          <p:nvPr/>
+        </p:nvSpPr>
+        <p:spPr>
+          <a:xfrm>
+            <a:off x="6263640" y="3867912"/>
+            <a:ext cx="640080" cy="219456"/>
+          </a:xfrm>
+          <a:prstGeom prst="rect">
+            <a:avLst/>
+          </a:prstGeom>
+          <a:noFill/>
+        </p:spPr>
+        <p:txBody>
+          <a:bodyPr wrap="square" lIns="0" tIns="0" rIns="0" bIns="0" rtlCol="0" anchor="ctr">
+            <a:noAutofit/>
+          </a:bodyPr>
+          <a:lstStyle/>
+          <a:p>
+            <a:pPr algn="l"/>
+            <a:r>
+              <a:rPr lang="ko-KR" altLang="en-US" sz="650" b="1" dirty="0">
+                <a:solidFill>
+                  <a:schemeClr val="tx1"/>
+                </a:solidFill>
+              </a:rPr>
+              <a:t>EngineCore</a:t>
+            </a:r>
+          </a:p>
+        </p:txBody>
+      </p:sp>
+      <p:sp>
+        <p:nvSpPr>
+          <p:cNvPr id="165" name="lane w"/>
+          <p:cNvSpPr txBox="1"/>
+          <p:nvPr/>
+        </p:nvSpPr>
+        <p:spPr>
+          <a:xfrm>
+            <a:off x="6263640" y="4160520"/>
+            <a:ext cx="640080" cy="219456"/>
+          </a:xfrm>
+          <a:prstGeom prst="rect">
+            <a:avLst/>
+          </a:prstGeom>
+          <a:noFill/>
+        </p:spPr>
+        <p:txBody>
+          <a:bodyPr wrap="square" lIns="0" tIns="0" rIns="0" bIns="0" rtlCol="0" anchor="ctr">
+            <a:noAutofit/>
+          </a:bodyPr>
+          <a:lstStyle/>
+          <a:p>
+            <a:pPr algn="l"/>
+            <a:r>
+              <a:rPr lang="ko-KR" altLang="en-US" sz="650" b="1" dirty="0">
+                <a:solidFill>
+                  <a:schemeClr val="tx1"/>
+                </a:solidFill>
+              </a:rPr>
+              <a:t>Worker</a:t>
+            </a:r>
+          </a:p>
+        </p:txBody>
+      </p:sp>
+      <p:sp>
+        <p:nvSpPr>
+          <p:cNvPr id="166" name="step"/>
+          <p:cNvSpPr txBox="1"/>
+          <p:nvPr/>
+        </p:nvSpPr>
+        <p:spPr>
+          <a:xfrm>
+            <a:off x="6931152" y="3730752"/>
+            <a:ext cx="1371600" cy="118872"/>
+          </a:xfrm>
+          <a:prstGeom prst="rect">
+            <a:avLst/>
+          </a:prstGeom>
+          <a:noFill/>
+        </p:spPr>
+        <p:txBody>
+          <a:bodyPr wrap="square" lIns="0" tIns="0" rIns="0" bIns="0" rtlCol="0" anchor="ctr">
+            <a:noAutofit/>
+          </a:bodyPr>
+          <a:lstStyle/>
+          <a:p>
+            <a:pPr algn="ctr"/>
+            <a:r>
+              <a:rPr lang="ko-KR" altLang="en-US" sz="600" dirty="0">
+                <a:solidFill>
+                  <a:srgbClr val="595959"/>
+                </a:solidFill>
+              </a:rPr>
+              <a:t>step n</a:t>
+            </a:r>
+          </a:p>
+        </p:txBody>
+      </p:sp>
+      <p:sp>
+        <p:nvSpPr>
+          <p:cNvPr id="167" name="ec bar"/>
+          <p:cNvSpPr/>
+          <p:nvPr/>
+        </p:nvSpPr>
+        <p:spPr>
+          <a:xfrm>
+            <a:off x="6949440" y="3867912"/>
+            <a:ext cx="1335024" cy="219456"/>
+          </a:xfrm>
+          <a:prstGeom prst="rect">
+            <a:avLst/>
+          </a:prstGeom>
+          <a:solidFill>
+            <a:srgbClr val="E7E6E6"/>
+          </a:solidFill>
+          <a:ln>
+            <a:noFill/>
+          </a:ln>
+        </p:spPr>
+        <p:style>
+          <a:lnRef idx="2">
+            <a:schemeClr val="accent1">
+              <a:shade val="50000"/>
+            </a:schemeClr>
+          </a:lnRef>
+          <a:fillRef idx="1">
+            <a:schemeClr val="accent1"/>
+          </a:fillRef>
+          <a:effectRef idx="0">
+            <a:schemeClr val="accent1"/>
+          </a:effectRef>
+          <a:fontRef idx="minor">
+            <a:schemeClr val="lt1"/>
+          </a:fontRef>
+        </p:style>
+        <p:txBody>
+          <a:bodyPr lIns="36000" tIns="18000" rIns="36000" bIns="18000" rtlCol="0" anchor="ctr">
+            <a:noAutofit/>
+          </a:bodyPr>
+          <a:lstStyle/>
+          <a:p>
+            <a:endParaRPr lang="ko-KR"/>
+          </a:p>
+        </p:txBody>
+      </p:sp>
+      <p:sp>
+        <p:nvSpPr>
+          <p:cNvPr id="168" name="w bar"/>
+          <p:cNvSpPr/>
+          <p:nvPr/>
+        </p:nvSpPr>
+        <p:spPr>
+          <a:xfrm>
+            <a:off x="6949440" y="4160520"/>
+            <a:ext cx="1335024" cy="219456"/>
+          </a:xfrm>
+          <a:prstGeom prst="rect">
+            <a:avLst/>
+          </a:prstGeom>
+          <a:solidFill>
+            <a:schemeClr val="accent6">
+              <a:lumMod val="20000"/>
+              <a:lumOff val="80000"/>
+            </a:schemeClr>
+          </a:solidFill>
+          <a:ln>
+            <a:noFill/>
+          </a:ln>
+        </p:spPr>
+        <p:style>
+          <a:lnRef idx="2">
+            <a:schemeClr val="accent1">
+              <a:shade val="50000"/>
+            </a:schemeClr>
+          </a:lnRef>
+          <a:fillRef idx="1">
+            <a:schemeClr val="accent1"/>
+          </a:fillRef>
+          <a:effectRef idx="0">
+            <a:schemeClr val="accent1"/>
+          </a:effectRef>
+          <a:fontRef idx="minor">
+            <a:schemeClr val="lt1"/>
+          </a:fontRef>
+        </p:style>
+        <p:txBody>
+          <a:bodyPr lIns="36000" tIns="18000" rIns="36000" bIns="18000" rtlCol="0" anchor="ctr">
+            <a:noAutofit/>
+          </a:bodyPr>
+          <a:lstStyle/>
+          <a:p>
+            <a:endParaRPr lang="ko-KR"/>
+          </a:p>
+        </p:txBody>
+      </p:sp>
+      <p:sp>
+        <p:nvSpPr>
+          <p:cNvPr id="169" name="step"/>
+          <p:cNvSpPr txBox="1"/>
+          <p:nvPr/>
+        </p:nvSpPr>
+        <p:spPr>
+          <a:xfrm>
+            <a:off x="8302752" y="3730752"/>
+            <a:ext cx="1554480" cy="118872"/>
+          </a:xfrm>
+          <a:prstGeom prst="rect">
+            <a:avLst/>
+          </a:prstGeom>
+          <a:noFill/>
+        </p:spPr>
+        <p:txBody>
+          <a:bodyPr wrap="square" lIns="0" tIns="0" rIns="0" bIns="0" rtlCol="0" anchor="ctr">
+            <a:noAutofit/>
+          </a:bodyPr>
+          <a:lstStyle/>
+          <a:p>
+            <a:pPr algn="ctr"/>
+            <a:r>
+              <a:rPr lang="ko-KR" altLang="en-US" sz="600" dirty="0">
+                <a:solidFill>
+                  <a:srgbClr val="595959"/>
+                </a:solidFill>
+              </a:rPr>
+              <a:t>step n+1</a:t>
+            </a:r>
+          </a:p>
+        </p:txBody>
+      </p:sp>
+      <p:sp>
+        <p:nvSpPr>
+          <p:cNvPr id="170" name="ec bar"/>
+          <p:cNvSpPr/>
+          <p:nvPr/>
+        </p:nvSpPr>
+        <p:spPr>
+          <a:xfrm>
+            <a:off x="8321040" y="3867912"/>
+            <a:ext cx="1517904" cy="219456"/>
+          </a:xfrm>
+          <a:prstGeom prst="rect">
+            <a:avLst/>
+          </a:prstGeom>
+          <a:solidFill>
+            <a:srgbClr val="E7E6E6"/>
+          </a:solidFill>
+          <a:ln>
+            <a:noFill/>
+          </a:ln>
+        </p:spPr>
+        <p:style>
+          <a:lnRef idx="2">
+            <a:schemeClr val="accent1">
+              <a:shade val="50000"/>
+            </a:schemeClr>
+          </a:lnRef>
+          <a:fillRef idx="1">
+            <a:schemeClr val="accent1"/>
+          </a:fillRef>
+          <a:effectRef idx="0">
+            <a:schemeClr val="accent1"/>
+          </a:effectRef>
+          <a:fontRef idx="minor">
+            <a:schemeClr val="lt1"/>
+          </a:fontRef>
+        </p:style>
+        <p:txBody>
+          <a:bodyPr lIns="36000" tIns="18000" rIns="36000" bIns="18000" rtlCol="0" anchor="ctr">
+            <a:noAutofit/>
+          </a:bodyPr>
+          <a:lstStyle/>
+          <a:p>
+            <a:endParaRPr lang="ko-KR"/>
+          </a:p>
+        </p:txBody>
+      </p:sp>
+      <p:sp>
+        <p:nvSpPr>
+          <p:cNvPr id="171" name="w bar"/>
+          <p:cNvSpPr/>
+          <p:nvPr/>
+        </p:nvSpPr>
+        <p:spPr>
+          <a:xfrm>
+            <a:off x="8321040" y="4160520"/>
+            <a:ext cx="1517904" cy="219456"/>
+          </a:xfrm>
+          <a:prstGeom prst="rect">
+            <a:avLst/>
+          </a:prstGeom>
+          <a:solidFill>
+            <a:schemeClr val="accent6">
+              <a:lumMod val="20000"/>
+              <a:lumOff val="80000"/>
+            </a:schemeClr>
+          </a:solidFill>
+          <a:ln>
+            <a:noFill/>
+          </a:ln>
+        </p:spPr>
+        <p:style>
+          <a:lnRef idx="2">
+            <a:schemeClr val="accent1">
+              <a:shade val="50000"/>
+            </a:schemeClr>
+          </a:lnRef>
+          <a:fillRef idx="1">
+            <a:schemeClr val="accent1"/>
+          </a:fillRef>
+          <a:effectRef idx="0">
+            <a:schemeClr val="accent1"/>
+          </a:effectRef>
+          <a:fontRef idx="minor">
+            <a:schemeClr val="lt1"/>
+          </a:fontRef>
+        </p:style>
+        <p:txBody>
+          <a:bodyPr lIns="36000" tIns="18000" rIns="36000" bIns="18000" rtlCol="0" anchor="ctr">
+            <a:noAutofit/>
+          </a:bodyPr>
+          <a:lstStyle/>
+          <a:p>
+            <a:endParaRPr lang="ko-KR"/>
+          </a:p>
+        </p:txBody>
+      </p:sp>
+      <p:sp>
+        <p:nvSpPr>
+          <p:cNvPr id="172" name="step"/>
+          <p:cNvSpPr txBox="1"/>
+          <p:nvPr/>
+        </p:nvSpPr>
+        <p:spPr>
+          <a:xfrm>
+            <a:off x="9857232" y="3730752"/>
+            <a:ext cx="1481328" cy="118872"/>
+          </a:xfrm>
+          <a:prstGeom prst="rect">
+            <a:avLst/>
+          </a:prstGeom>
+          <a:noFill/>
+        </p:spPr>
+        <p:txBody>
+          <a:bodyPr wrap="square" lIns="0" tIns="0" rIns="0" bIns="0" rtlCol="0" anchor="ctr">
+            <a:noAutofit/>
+          </a:bodyPr>
+          <a:lstStyle/>
+          <a:p>
+            <a:pPr algn="ctr"/>
+            <a:r>
+              <a:rPr lang="ko-KR" altLang="en-US" sz="600" dirty="0">
+                <a:solidFill>
+                  <a:srgbClr val="595959"/>
+                </a:solidFill>
+              </a:rPr>
+              <a:t>step n+2</a:t>
+            </a:r>
+          </a:p>
+        </p:txBody>
+      </p:sp>
+      <p:sp>
+        <p:nvSpPr>
+          <p:cNvPr id="173" name="ec bar"/>
+          <p:cNvSpPr/>
+          <p:nvPr/>
+        </p:nvSpPr>
+        <p:spPr>
+          <a:xfrm>
+            <a:off x="9875520" y="3867912"/>
+            <a:ext cx="1444752" cy="219456"/>
+          </a:xfrm>
+          <a:prstGeom prst="rect">
+            <a:avLst/>
+          </a:prstGeom>
+          <a:solidFill>
+            <a:srgbClr val="E7E6E6"/>
+          </a:solidFill>
+          <a:ln>
+            <a:noFill/>
+          </a:ln>
+        </p:spPr>
+        <p:style>
+          <a:lnRef idx="2">
+            <a:schemeClr val="accent1">
+              <a:shade val="50000"/>
+            </a:schemeClr>
+          </a:lnRef>
+          <a:fillRef idx="1">
+            <a:schemeClr val="accent1"/>
+          </a:fillRef>
+          <a:effectRef idx="0">
+            <a:schemeClr val="accent1"/>
+          </a:effectRef>
+          <a:fontRef idx="minor">
+            <a:schemeClr val="lt1"/>
+          </a:fontRef>
+        </p:style>
+        <p:txBody>
+          <a:bodyPr lIns="36000" tIns="18000" rIns="36000" bIns="18000" rtlCol="0" anchor="ctr">
+            <a:noAutofit/>
+          </a:bodyPr>
+          <a:lstStyle/>
+          <a:p>
+            <a:endParaRPr lang="ko-KR"/>
+          </a:p>
+        </p:txBody>
+      </p:sp>
+      <p:sp>
+        <p:nvSpPr>
+          <p:cNvPr id="174" name="w bar"/>
+          <p:cNvSpPr/>
+          <p:nvPr/>
+        </p:nvSpPr>
+        <p:spPr>
+          <a:xfrm>
+            <a:off x="9875520" y="4160520"/>
+            <a:ext cx="1444752" cy="219456"/>
+          </a:xfrm>
+          <a:prstGeom prst="rect">
+            <a:avLst/>
+          </a:prstGeom>
+          <a:solidFill>
+            <a:schemeClr val="accent6">
+              <a:lumMod val="20000"/>
+              <a:lumOff val="80000"/>
+            </a:schemeClr>
+          </a:solidFill>
+          <a:ln>
+            <a:noFill/>
+          </a:ln>
+        </p:spPr>
+        <p:style>
+          <a:lnRef idx="2">
+            <a:schemeClr val="accent1">
+              <a:shade val="50000"/>
+            </a:schemeClr>
+          </a:lnRef>
+          <a:fillRef idx="1">
+            <a:schemeClr val="accent1"/>
+          </a:fillRef>
+          <a:effectRef idx="0">
+            <a:schemeClr val="accent1"/>
+          </a:effectRef>
+          <a:fontRef idx="minor">
+            <a:schemeClr val="lt1"/>
+          </a:fontRef>
+        </p:style>
+        <p:txBody>
+          <a:bodyPr lIns="36000" tIns="18000" rIns="36000" bIns="18000" rtlCol="0" anchor="ctr">
+            <a:noAutofit/>
+          </a:bodyPr>
+          <a:lstStyle/>
+          <a:p>
+            <a:endParaRPr lang="ko-KR"/>
+          </a:p>
+        </p:txBody>
+      </p:sp>
+      <p:sp>
+        <p:nvSpPr>
+          <p:cNvPr id="175" name="l"/>
+          <p:cNvSpPr txBox="1"/>
+          <p:nvPr/>
+        </p:nvSpPr>
+        <p:spPr>
+          <a:xfrm>
+            <a:off x="6976872" y="4178808"/>
+            <a:ext cx="502920" cy="182880"/>
+          </a:xfrm>
+          <a:prstGeom prst="rect">
+            <a:avLst/>
+          </a:prstGeom>
+          <a:noFill/>
+        </p:spPr>
+        <p:txBody>
+          <a:bodyPr wrap="square" lIns="0" tIns="0" rIns="0" bIns="0" rtlCol="0" anchor="ctr">
+            <a:noAutofit/>
+          </a:bodyPr>
+          <a:lstStyle/>
+          <a:p>
+            <a:pPr algn="l"/>
+            <a:r>
+              <a:rPr lang="ko-KR" altLang="en-US" sz="600" dirty="0">
+                <a:solidFill>
+                  <a:srgbClr val="595959"/>
+                </a:solidFill>
+              </a:rPr>
+              <a:t>lease(n)</a:t>
+            </a:r>
+          </a:p>
+        </p:txBody>
+      </p:sp>
+      <p:sp>
+        <p:nvSpPr>
+          <p:cNvPr id="176" name="copy done"/>
+          <p:cNvSpPr/>
+          <p:nvPr/>
+        </p:nvSpPr>
+        <p:spPr>
+          <a:xfrm>
+            <a:off x="8097012" y="4201668"/>
+            <a:ext cx="137160" cy="137160"/>
+          </a:xfrm>
+          <a:prstGeom prst="ellipse">
+            <a:avLst/>
+          </a:prstGeom>
+          <a:solidFill>
+            <a:schemeClr val="tx1"/>
+          </a:solidFill>
+          <a:ln w="9525">
+            <a:solidFill>
+              <a:schemeClr val="tx1"/>
+            </a:solidFill>
+          </a:ln>
+        </p:spPr>
+        <p:style>
+          <a:lnRef idx="2">
+            <a:schemeClr val="accent1">
+              <a:shade val="50000"/>
+            </a:schemeClr>
+          </a:lnRef>
+          <a:fillRef idx="1">
+            <a:schemeClr val="accent1"/>
+          </a:fillRef>
+          <a:effectRef idx="0">
+            <a:schemeClr val="accent1"/>
+          </a:effectRef>
+          <a:fontRef idx="minor">
+            <a:schemeClr val="lt1"/>
+          </a:fontRef>
+        </p:style>
+        <p:txBody>
+          <a:bodyPr lIns="36000" tIns="18000" rIns="36000" bIns="18000" rtlCol="0" anchor="ctr">
+            <a:noAutofit/>
+          </a:bodyPr>
+          <a:lstStyle/>
+          <a:p>
+            <a:endParaRPr lang="ko-KR"/>
+          </a:p>
+        </p:txBody>
+      </p:sp>
+      <p:sp>
+        <p:nvSpPr>
+          <p:cNvPr id="177" name="l"/>
+          <p:cNvSpPr txBox="1"/>
+          <p:nvPr/>
+        </p:nvSpPr>
+        <p:spPr>
+          <a:xfrm>
+            <a:off x="7498080" y="4178808"/>
+            <a:ext cx="594360" cy="182880"/>
+          </a:xfrm>
+          <a:prstGeom prst="rect">
+            <a:avLst/>
+          </a:prstGeom>
+          <a:noFill/>
+        </p:spPr>
+        <p:txBody>
+          <a:bodyPr wrap="square" lIns="0" tIns="0" rIns="0" bIns="0" rtlCol="0" anchor="ctr">
+            <a:noAutofit/>
+          </a:bodyPr>
+          <a:lstStyle/>
           <a:p>
             <a:pPr algn="l"/>
             <a:r>
@@ -19054,9 +19427,198 @@
                   <a:schemeClr val="tx1"/>
                 </a:solidFill>
               </a:rPr>
-              <a:t>노랑 EngineCore · 연두 Worker</a:t>
+              <a:t>copy 완료</a:t>
             </a:r>
           </a:p>
+        </p:txBody>
+      </p:sp>
+      <p:sp>
+        <p:nvSpPr>
+          <p:cNvPr id="178" name="flip"/>
+          <p:cNvSpPr/>
+          <p:nvPr/>
+        </p:nvSpPr>
+        <p:spPr>
+          <a:xfrm>
+            <a:off x="8343900" y="4201668"/>
+            <a:ext cx="137160" cy="137160"/>
+          </a:xfrm>
+          <a:prstGeom prst="ellipse">
+            <a:avLst/>
+          </a:prstGeom>
+          <a:solidFill>
+            <a:srgbClr val="C00000"/>
+          </a:solidFill>
+          <a:ln w="9525">
+            <a:solidFill>
+              <a:schemeClr val="tx1"/>
+            </a:solidFill>
+          </a:ln>
+        </p:spPr>
+        <p:style>
+          <a:lnRef idx="2">
+            <a:schemeClr val="accent1">
+              <a:shade val="50000"/>
+            </a:schemeClr>
+          </a:lnRef>
+          <a:fillRef idx="1">
+            <a:schemeClr val="accent1"/>
+          </a:fillRef>
+          <a:effectRef idx="0">
+            <a:schemeClr val="accent1"/>
+          </a:effectRef>
+          <a:fontRef idx="minor">
+            <a:schemeClr val="lt1"/>
+          </a:fontRef>
+        </p:style>
+        <p:txBody>
+          <a:bodyPr lIns="36000" tIns="18000" rIns="36000" bIns="18000" rtlCol="0" anchor="ctr">
+            <a:noAutofit/>
+          </a:bodyPr>
+          <a:lstStyle/>
+          <a:p>
+            <a:endParaRPr lang="ko-KR"/>
+          </a:p>
+        </p:txBody>
+      </p:sp>
+      <p:sp>
+        <p:nvSpPr>
+          <p:cNvPr id="179" name="l"/>
+          <p:cNvSpPr txBox="1"/>
+          <p:nvPr/>
+        </p:nvSpPr>
+        <p:spPr>
+          <a:xfrm>
+            <a:off x="8503920" y="4178808"/>
+            <a:ext cx="1280160" cy="182880"/>
+          </a:xfrm>
+          <a:prstGeom prst="rect">
+            <a:avLst/>
+          </a:prstGeom>
+          <a:noFill/>
+        </p:spPr>
+        <p:txBody>
+          <a:bodyPr wrap="square" lIns="0" tIns="0" rIns="0" bIns="0" rtlCol="0" anchor="ctr">
+            <a:noAutofit/>
+          </a:bodyPr>
+          <a:lstStyle/>
+          <a:p>
+            <a:pPr algn="l"/>
+            <a:r>
+              <a:rPr lang="ko-KR" altLang="en-US" sz="600" b="1" dirty="0">
+                <a:solidFill>
+                  <a:srgbClr val="C00000"/>
+                </a:solidFill>
+              </a:rPr>
+              <a:t>다음 Worker step 시작 시 flip</a:t>
+            </a:r>
+          </a:p>
+        </p:txBody>
+      </p:sp>
+      <p:sp>
+        <p:nvSpPr>
+          <p:cNvPr id="180" name="l"/>
+          <p:cNvSpPr txBox="1"/>
+          <p:nvPr/>
+        </p:nvSpPr>
+        <p:spPr>
+          <a:xfrm>
+            <a:off x="6976872" y="3886200"/>
+            <a:ext cx="1280160" cy="182880"/>
+          </a:xfrm>
+          <a:prstGeom prst="rect">
+            <a:avLst/>
+          </a:prstGeom>
+          <a:noFill/>
+        </p:spPr>
+        <p:txBody>
+          <a:bodyPr wrap="square" lIns="0" tIns="0" rIns="0" bIns="0" rtlCol="0" anchor="ctr">
+            <a:noAutofit/>
+          </a:bodyPr>
+          <a:lstStyle/>
+          <a:p>
+            <a:pPr algn="l"/>
+            <a:r>
+              <a:rPr lang="ko-KR" altLang="en-US" sz="600" dirty="0">
+                <a:solidFill>
+                  <a:srgbClr val="595959"/>
+                </a:solidFill>
+              </a:rPr>
+              <a:t>(복사 중) 매핑 v7 유지</a:t>
+            </a:r>
+          </a:p>
+        </p:txBody>
+      </p:sp>
+      <p:sp>
+        <p:nvSpPr>
+          <p:cNvPr id="181" name="event"/>
+          <p:cNvSpPr/>
+          <p:nvPr/>
+        </p:nvSpPr>
+        <p:spPr>
+          <a:xfrm>
+            <a:off x="8737092" y="3909060"/>
+            <a:ext cx="137160" cy="137160"/>
+          </a:xfrm>
+          <a:prstGeom prst="ellipse">
+            <a:avLst/>
+          </a:prstGeom>
+          <a:solidFill>
+            <a:schemeClr val="bg1"/>
+          </a:solidFill>
+          <a:ln w="9525">
+            <a:solidFill>
+              <a:schemeClr val="tx1"/>
+            </a:solidFill>
+          </a:ln>
+        </p:spPr>
+        <p:style>
+          <a:lnRef idx="2">
+            <a:schemeClr val="accent1">
+              <a:shade val="50000"/>
+            </a:schemeClr>
+          </a:lnRef>
+          <a:fillRef idx="1">
+            <a:schemeClr val="accent1"/>
+          </a:fillRef>
+          <a:effectRef idx="0">
+            <a:schemeClr val="accent1"/>
+          </a:effectRef>
+          <a:fontRef idx="minor">
+            <a:schemeClr val="lt1"/>
+          </a:fontRef>
+        </p:style>
+        <p:txBody>
+          <a:bodyPr lIns="36000" tIns="18000" rIns="36000" bIns="18000" rtlCol="0" anchor="ctr">
+            <a:noAutofit/>
+          </a:bodyPr>
+          <a:lstStyle/>
+          <a:p>
+            <a:endParaRPr lang="ko-KR"/>
+          </a:p>
+        </p:txBody>
+      </p:sp>
+      <p:sp>
+        <p:nvSpPr>
+          <p:cNvPr id="182" name="l"/>
+          <p:cNvSpPr txBox="1"/>
+          <p:nvPr/>
+        </p:nvSpPr>
+        <p:spPr>
+          <a:xfrm>
+            <a:off x="8897112" y="3886200"/>
+            <a:ext cx="914400" cy="182880"/>
+          </a:xfrm>
+          <a:prstGeom prst="rect">
+            <a:avLst/>
+          </a:prstGeom>
+          <a:noFill/>
+        </p:spPr>
+        <p:txBody>
+          <a:bodyPr wrap="square" lIns="0" tIns="0" rIns="0" bIns="0" rtlCol="0" anchor="ctr">
+            <a:noAutofit/>
+          </a:bodyPr>
+          <a:lstStyle/>
           <a:p>
             <a:pPr algn="l"/>
             <a:r>
@@ -19065,20 +19627,103 @@
                   <a:schemeClr val="tx1"/>
                 </a:solidFill>
               </a:rPr>
-              <a:t>(Control Plane 이 두 프로세스에 걸침)</a:t>
+              <a:t>event → mirror 갱신</a:t>
+            </a:r>
+          </a:p>
+        </p:txBody>
+      </p:sp>
+      <p:cxnSp>
+        <p:nvCxnSpPr>
+          <p:cNvPr id="183" name="ev"/>
+          <p:cNvCxnSpPr/>
+          <p:nvPr/>
+        </p:nvCxnSpPr>
+        <p:spPr>
+          <a:xfrm flipV="1">
+            <a:off x="8412480" y="4041648"/>
+            <a:ext cx="393192" cy="164592"/>
+          </a:xfrm>
+          <a:prstGeom prst="line">
+            <a:avLst/>
+          </a:prstGeom>
+          <a:ln w="9525">
+            <a:solidFill>
+              <a:schemeClr val="tx1"/>
+            </a:solidFill>
+            <a:prstDash val="sysDot"/>
+            <a:tailEnd type="arrow"/>
+          </a:ln>
+        </p:spPr>
+      </p:cxnSp>
+      <p:sp>
+        <p:nvSpPr>
+          <p:cNvPr id="184" name="l"/>
+          <p:cNvSpPr txBox="1"/>
+          <p:nvPr/>
+        </p:nvSpPr>
+        <p:spPr>
+          <a:xfrm>
+            <a:off x="9902952" y="4178808"/>
+            <a:ext cx="1371600" cy="182880"/>
+          </a:xfrm>
+          <a:prstGeom prst="rect">
+            <a:avLst/>
+          </a:prstGeom>
+          <a:noFill/>
+        </p:spPr>
+        <p:txBody>
+          <a:bodyPr wrap="square" lIns="0" tIns="0" rIns="0" bIns="0" rtlCol="0" anchor="ctr">
+            <a:noAutofit/>
+          </a:bodyPr>
+          <a:lstStyle/>
+          <a:p>
+            <a:pPr algn="l"/>
+            <a:r>
+              <a:rPr lang="ko-KR" altLang="en-US" sz="600" dirty="0">
+                <a:solidFill>
+                  <a:srgbClr val="595959"/>
+                </a:solidFill>
+              </a:rPr>
+              <a:t>lease(n) 소진 후 slot 해제</a:t>
             </a:r>
           </a:p>
         </p:txBody>
       </p:sp>
       <p:sp>
         <p:nvSpPr>
-          <p:cNvPr id="161" name="adv"/>
+          <p:cNvPr id="185" name="tl leg"/>
           <p:cNvSpPr txBox="1"/>
           <p:nvPr/>
         </p:nvSpPr>
         <p:spPr>
           <a:xfrm>
-            <a:off x="274320" y="4389120"/>
+            <a:off x="6263640" y="4379976"/>
+            <a:ext cx="5303520" cy="100584"/>
+          </a:xfrm>
+          <a:prstGeom prst="rect">
+            <a:avLst/>
+          </a:prstGeom>
+          <a:noFill/>
+        </p:spPr>
+        <p:txBody>
+          <a:bodyPr wrap="square" lIns="0" tIns="0" rIns="0" bIns="0" rtlCol="0" anchor="ctr">
+            <a:noAutofit/>
+          </a:bodyPr>
+          <a:lstStyle/>
+          <a:p>
+            <a:pPr algn="l"/>
+          </a:p>
+        </p:txBody>
+      </p:sp>
+      <p:sp>
+        <p:nvSpPr>
+          <p:cNvPr id="186" name="adv"/>
+          <p:cNvSpPr txBox="1"/>
+          <p:nvPr/>
+        </p:nvSpPr>
+        <p:spPr>
+          <a:xfrm>
+            <a:off x="274320" y="4553712"/>
             <a:ext cx="457200" cy="274320"/>
           </a:xfrm>
           <a:prstGeom prst="rect">
@@ -19106,7 +19751,7 @@
       </p:sp>
       <p:sp>
         <p:nvSpPr>
-          <p:cNvPr id="162" name="dis"/>
+          <p:cNvPr id="187" name="dis"/>
           <p:cNvSpPr txBox="1"/>
           <p:nvPr/>
         </p:nvSpPr>
@@ -19140,14 +19785,14 @@
       </p:sp>
       <p:sp>
         <p:nvSpPr>
-          <p:cNvPr id="163" name="c1 adv"/>
+          <p:cNvPr id="188" name="c1 adv"/>
           <p:cNvSpPr/>
           <p:nvPr/>
         </p:nvSpPr>
         <p:spPr>
           <a:xfrm>
-            <a:off x="731520" y="4297680"/>
-            <a:ext cx="5303520" cy="1069848"/>
+            <a:off x="731520" y="4480560"/>
+            <a:ext cx="5212080" cy="914400"/>
           </a:xfrm>
           <a:prstGeom prst="rect">
             <a:avLst/>
@@ -19184,7 +19829,7 @@
               <a:buChar char="•"/>
             </a:pPr>
             <a:r>
-              <a:rPr lang="ko-KR" altLang="en-US" sz="820" dirty="0">
+              <a:rPr lang="ko-KR" altLang="en-US" sz="780" dirty="0">
                 <a:solidFill>
                   <a:schemeClr val="tx1"/>
                 </a:solidFill>
@@ -19198,7 +19843,7 @@
               <a:buChar char="•"/>
             </a:pPr>
             <a:r>
-              <a:rPr lang="ko-KR" altLang="en-US" sz="820" dirty="0">
+              <a:rPr lang="ko-KR" altLang="en-US" sz="780" dirty="0">
                 <a:solidFill>
                   <a:schemeClr val="tx1"/>
                 </a:solidFill>
@@ -19212,7 +19857,7 @@
               <a:buChar char="•"/>
             </a:pPr>
             <a:r>
-              <a:rPr lang="ko-KR" altLang="en-US" sz="820" dirty="0">
+              <a:rPr lang="ko-KR" altLang="en-US" sz="780" dirty="0">
                 <a:solidFill>
                   <a:schemeClr val="tx1"/>
                 </a:solidFill>
@@ -19226,7 +19871,7 @@
               <a:buChar char="•"/>
             </a:pPr>
             <a:r>
-              <a:rPr lang="ko-KR" altLang="en-US" sz="820" dirty="0">
+              <a:rPr lang="ko-KR" altLang="en-US" sz="780" dirty="0">
                 <a:solidFill>
                   <a:schemeClr val="tx1"/>
                 </a:solidFill>
@@ -19240,7 +19885,7 @@
               <a:buChar char="•"/>
             </a:pPr>
             <a:r>
-              <a:rPr lang="ko-KR" altLang="en-US" sz="820" dirty="0">
+              <a:rPr lang="ko-KR" altLang="en-US" sz="780" dirty="0">
                 <a:solidFill>
                   <a:schemeClr val="tx1"/>
                 </a:solidFill>
@@ -19252,14 +19897,14 @@
       </p:sp>
       <p:sp>
         <p:nvSpPr>
-          <p:cNvPr id="164" name="c1 dis"/>
+          <p:cNvPr id="189" name="c1 dis"/>
           <p:cNvSpPr/>
           <p:nvPr/>
         </p:nvSpPr>
         <p:spPr>
           <a:xfrm>
-            <a:off x="731520" y="5394960"/>
-            <a:ext cx="5303520" cy="1005840"/>
+            <a:off x="731520" y="5413248"/>
+            <a:ext cx="5212080" cy="960120"/>
           </a:xfrm>
           <a:prstGeom prst="rect">
             <a:avLst/>
@@ -19296,7 +19941,7 @@
               <a:buChar char="•"/>
             </a:pPr>
             <a:r>
-              <a:rPr lang="ko-KR" altLang="en-US" sz="820" dirty="0">
+              <a:rPr lang="ko-KR" altLang="en-US" sz="780" dirty="0">
                 <a:solidFill>
                   <a:schemeClr val="tx1"/>
                 </a:solidFill>
@@ -19310,12 +19955,12 @@
               <a:buChar char="•"/>
             </a:pPr>
             <a:r>
-              <a:rPr lang="ko-KR" altLang="en-US" sz="820" dirty="0">
+              <a:rPr lang="ko-KR" altLang="en-US" sz="780" dirty="0">
                 <a:solidFill>
                   <a:schemeClr val="tx1"/>
                 </a:solidFill>
               </a:rPr>
-              <a:t>commit · 해제가 step 경계에 양자화 (반영이 1~2 step 지연)</a:t>
+              <a:t>commit · 해제가 step 경계에 양자화 (반영 1~2 step 지연)</a:t>
             </a:r>
           </a:p>
           <a:p>
@@ -19324,7 +19969,7 @@
               <a:buChar char="•"/>
             </a:pPr>
             <a:r>
-              <a:rPr lang="ko-KR" altLang="en-US" sz="820" dirty="0">
+              <a:rPr lang="ko-KR" altLang="en-US" sz="780" dirty="0">
                 <a:solidFill>
                   <a:schemeClr val="tx1"/>
                 </a:solidFill>
@@ -19338,26 +19983,26 @@
               <a:buChar char="•"/>
             </a:pPr>
             <a:r>
-              <a:rPr lang="ko-KR" altLang="en-US" sz="820" dirty="0">
+              <a:rPr lang="ko-KR" altLang="en-US" sz="780" dirty="0">
                 <a:solidFill>
                   <a:schemeClr val="tx1"/>
                 </a:solidFill>
               </a:rPr>
-              <a:t>scheduler.py, output.py, kv_cache_manager.py, block_pool.py 수정 → upstream 추종 부담</a:t>
+              <a:t>scheduler.py 등 엔진 코어 수정 → upstream 추종 부담</a:t>
             </a:r>
           </a:p>
         </p:txBody>
       </p:sp>
       <p:sp>
         <p:nvSpPr>
-          <p:cNvPr id="165" name="c2 adv"/>
+          <p:cNvPr id="190" name="c2 adv"/>
           <p:cNvSpPr/>
           <p:nvPr/>
         </p:nvSpPr>
         <p:spPr>
           <a:xfrm>
-            <a:off x="6217920" y="4297680"/>
-            <a:ext cx="5669280" cy="1069848"/>
+            <a:off x="6217920" y="4480560"/>
+            <a:ext cx="5669280" cy="914400"/>
           </a:xfrm>
           <a:prstGeom prst="rect">
             <a:avLst/>
@@ -19394,12 +20039,12 @@
               <a:buChar char="•"/>
             </a:pPr>
             <a:r>
-              <a:rPr lang="ko-KR" altLang="en-US" sz="820" dirty="0">
+              <a:rPr lang="ko-KR" altLang="en-US" sz="780" dirty="0">
                 <a:solidFill>
                   <a:schemeClr val="tx1"/>
                 </a:solidFill>
               </a:rPr>
-              <a:t>commit 이 Scheduler 루프를 거치지 않음 → EngineCore 병목 없고 Worker 별 분산</a:t>
+              <a:t>commit 이 Scheduler 의 commit 로직 · 완료 왕복을 거치지 않음 → EngineCore 직렬화 부담 감소</a:t>
             </a:r>
           </a:p>
           <a:p>
@@ -19408,12 +20053,12 @@
               <a:buChar char="•"/>
             </a:pPr>
             <a:r>
-              <a:rPr lang="ko-KR" altLang="en-US" sz="820" dirty="0">
+              <a:rPr lang="ko-KR" altLang="en-US" sz="780" dirty="0">
                 <a:solidFill>
                   <a:schemeClr val="tx1"/>
                 </a:solidFill>
               </a:rPr>
-              <a:t>복사 완료 후 다음 Worker step 에 즉시 반영, 한 Worker 의 느린 복사가 배치를 안 묶음</a:t>
+              <a:t>복사 완료 후 다음 Worker step 에 반영, 느린 복사가 배치 전체를 안 묶음</a:t>
             </a:r>
           </a:p>
           <a:p>
@@ -19422,7 +20067,7 @@
               <a:buChar char="•"/>
             </a:pPr>
             <a:r>
-              <a:rPr lang="ko-KR" altLang="en-US" sz="820" dirty="0">
+              <a:rPr lang="ko-KR" altLang="en-US" sz="780" dirty="0">
                 <a:solidFill>
                   <a:schemeClr val="tx1"/>
                 </a:solidFill>
@@ -19436,7 +20081,7 @@
               <a:buChar char="•"/>
             </a:pPr>
             <a:r>
-              <a:rPr lang="ko-KR" altLang="en-US" sz="820" dirty="0">
+              <a:rPr lang="ko-KR" altLang="en-US" sz="780" dirty="0">
                 <a:solidFill>
                   <a:schemeClr val="tx1"/>
                 </a:solidFill>
@@ -19448,14 +20093,14 @@
       </p:sp>
       <p:sp>
         <p:nvSpPr>
-          <p:cNvPr id="166" name="c2 dis"/>
+          <p:cNvPr id="191" name="c2 dis"/>
           <p:cNvSpPr/>
           <p:nvPr/>
         </p:nvSpPr>
         <p:spPr>
           <a:xfrm>
-            <a:off x="6217920" y="5394960"/>
-            <a:ext cx="5669280" cy="1005840"/>
+            <a:off x="6217920" y="5413248"/>
+            <a:ext cx="5669280" cy="960120"/>
           </a:xfrm>
           <a:prstGeom prst="rect">
             <a:avLst/>
@@ -19492,7 +20137,7 @@
               <a:buChar char="•"/>
             </a:pPr>
             <a:r>
-              <a:rPr lang="ko-KR" altLang="en-US" sz="820" dirty="0">
+              <a:rPr lang="ko-KR" altLang="en-US" sz="780" dirty="0">
                 <a:solidFill>
                   <a:schemeClr val="tx1"/>
                 </a:solidFill>
@@ -19506,7 +20151,7 @@
               <a:buChar char="•"/>
             </a:pPr>
             <a:r>
-              <a:rPr lang="ko-KR" altLang="en-US" sz="820" dirty="0">
+              <a:rPr lang="ko-KR" altLang="en-US" sz="780" dirty="0">
                 <a:solidFill>
                   <a:schemeClr val="tx1"/>
                 </a:solidFill>
@@ -19520,7 +20165,7 @@
               <a:buChar char="•"/>
             </a:pPr>
             <a:r>
-              <a:rPr lang="ko-KR" altLang="en-US" sz="820" dirty="0">
+              <a:rPr lang="ko-KR" altLang="en-US" sz="780" dirty="0">
                 <a:solidFill>
                   <a:schemeClr val="tx1"/>
                 </a:solidFill>
@@ -19534,7 +20179,7 @@
               <a:buChar char="•"/>
             </a:pPr>
             <a:r>
-              <a:rPr lang="ko-KR" altLang="en-US" sz="820" dirty="0">
+              <a:rPr lang="ko-KR" altLang="en-US" sz="780" dirty="0">
                 <a:solidFill>
                   <a:schemeClr val="tx1"/>
                 </a:solidFill>

</xml_diff>